<commit_message>
Point decks at the real GitHub repo
Replace the placeholder repo URL with github.com/AviatorRoyal/cloud-burst
in both review decks, and update the Review 2 repo tree to match the
actual project layout.

Co-Authored-By: AviatorRoyal <AviatorRoyal@users.noreply.github.com>
</commit_message>
<xml_diff>
--- a/P11_Review1_Problem_Formulation_and_Baseline.pptx
+++ b/P11_Review1_Problem_Formulation_and_Baseline.pptx
@@ -121,39 +121,39 @@
   <p:extLst>
     <p:ext uri="{521415D9-36F7-43E2-AB2F-B90AF26B5E84}">
       <p14:sectionLst xmlns:p14="http://schemas.microsoft.com/office/powerpoint/2010/main">
-        <p14:section name="Introduction" id="{4f7acb05-48f9-2d4d-bfc4-16350d25b4c2}">
+        <p14:section name="Introduction" id="{a9473b31-c305-699e-0fd6-8613b4e57191}">
           <p14:sldIdLst>
             <p14:sldId id="256"/>
             <p14:sldId id="257"/>
           </p14:sldIdLst>
         </p14:section>
-        <p14:section name="Problem" id="{5196393c-c421-266d-5d10-3982ca835bee}">
+        <p14:section name="Problem" id="{cb69a9fc-8421-d92c-f9ac-f9fa85af7527}">
           <p14:sldIdLst>
             <p14:sldId id="258"/>
             <p14:sldId id="259"/>
             <p14:sldId id="260"/>
           </p14:sldIdLst>
         </p14:section>
-        <p14:section name="Literature" id="{c46979f4-dcad-b1d4-30c0-70bd70d07b6e}">
+        <p14:section name="Literature" id="{2e9677eb-45dd-b414-86b4-643d6ee1f92d}">
           <p14:sldIdLst>
             <p14:sldId id="261"/>
             <p14:sldId id="262"/>
             <p14:sldId id="263"/>
           </p14:sldIdLst>
         </p14:section>
-        <p14:section name="Testbed" id="{8866b128-16e5-013a-0cec-fb4db63f1c32}">
+        <p14:section name="Testbed" id="{38e688d6-41c1-0c15-097c-b428dd07c1ed}">
           <p14:sldIdLst>
             <p14:sldId id="264"/>
             <p14:sldId id="265"/>
           </p14:sldIdLst>
         </p14:section>
-        <p14:section name="Baseline" id="{e06b5374-21d9-c288-baff-4eb0f171bfd5}">
+        <p14:section name="Baseline" id="{bf2386a5-4093-59ec-e9b4-213198bc34e0}">
           <p14:sldIdLst>
             <p14:sldId id="266"/>
             <p14:sldId id="267"/>
           </p14:sldIdLst>
         </p14:section>
-        <p14:section name="Plan" id="{e8314461-1901-0947-e7de-e88912431154}">
+        <p14:section name="Plan" id="{bc9de1d6-f2d3-6c05-f3e0-6dea0e865bcf}">
           <p14:sldIdLst>
             <p14:sldId id="268"/>
             <p14:sldId id="269"/>
@@ -7438,7 +7438,7 @@
                   <a:srgbClr val="1B2430"/>
                 </a:solidFill>
               </a:rPr>
-              <a:t>github.com/&lt;team&gt;/p11-cloud-bursting — controller, baselines, Locust shapes, experiment runner and analysis notebooks, all version-controlled from day one.</a:t>
+              <a:t>github.com/AviatorRoyal/cloud-burst — controller, baselines, Locust shapes, experiment runner and analysis scripts, all version-controlled from day one.</a:t>
             </a:r>
             <a:endParaRPr lang="en-US" sz="1500" dirty="0"/>
           </a:p>

</xml_diff>

<commit_message>
Final decks for all three reviews and the research paper
- Review 1 and 2 rebuilt from measured testbed and simulation data
  (no placeholders); previous-review wording removed from Review 2
- Review 3 (final) deck
- Research paper (21 pages, .docx and .pdf) generated from the results

Co-Authored-By: AviatorRoyal <AviatorRoyal@users.noreply.github.com>
</commit_message>
<xml_diff>
--- a/P11_Review1_Problem_Formulation_and_Baseline.pptx
+++ b/P11_Review1_Problem_Formulation_and_Baseline.pptx
@@ -121,39 +121,39 @@
   <p:extLst>
     <p:ext uri="{521415D9-36F7-43E2-AB2F-B90AF26B5E84}">
       <p14:sectionLst xmlns:p14="http://schemas.microsoft.com/office/powerpoint/2010/main">
-        <p14:section name="Introduction" id="{a9473b31-c305-699e-0fd6-8613b4e57191}">
+        <p14:section name="Introduction" id="{57284e21-91ed-3d9c-e6ef-8ca67ff5524b}">
           <p14:sldIdLst>
             <p14:sldId id="256"/>
             <p14:sldId id="257"/>
           </p14:sldIdLst>
         </p14:section>
-        <p14:section name="Problem" id="{cb69a9fc-8421-d92c-f9ac-f9fa85af7527}">
+        <p14:section name="Problem" id="{544fb17d-d57a-e491-6e0c-951224192982}">
           <p14:sldIdLst>
             <p14:sldId id="258"/>
             <p14:sldId id="259"/>
             <p14:sldId id="260"/>
           </p14:sldIdLst>
         </p14:section>
-        <p14:section name="Literature" id="{2e9677eb-45dd-b414-86b4-643d6ee1f92d}">
+        <p14:section name="Literature" id="{8309211a-04eb-b04a-cc30-d15b53caedaa}">
           <p14:sldIdLst>
             <p14:sldId id="261"/>
             <p14:sldId id="262"/>
             <p14:sldId id="263"/>
           </p14:sldIdLst>
         </p14:section>
-        <p14:section name="Testbed" id="{38e688d6-41c1-0c15-097c-b428dd07c1ed}">
+        <p14:section name="Testbed" id="{0cdbe5bc-c780-2a1b-a4c0-52ed885dbf8b}">
           <p14:sldIdLst>
             <p14:sldId id="264"/>
             <p14:sldId id="265"/>
           </p14:sldIdLst>
         </p14:section>
-        <p14:section name="Baseline" id="{bf2386a5-4093-59ec-e9b4-213198bc34e0}">
+        <p14:section name="Baseline" id="{aa6479c7-1d1a-c15c-d04e-34f2aec6647d}">
           <p14:sldIdLst>
             <p14:sldId id="266"/>
             <p14:sldId id="267"/>
           </p14:sldIdLst>
         </p14:section>
-        <p14:section name="Plan" id="{bc9de1d6-f2d3-6c05-f3e0-6dea0e865bcf}">
+        <p14:section name="Plan" id="{fe0036c4-b0fb-1b9d-706c-550dec6e47c5}">
           <p14:sldIdLst>
             <p14:sldId id="268"/>
             <p14:sldId id="269"/>
@@ -754,6 +754,817 @@
 </c:chartSpace>
 </file>
 
+<file path=ppt/charts/chart2.xml><?xml version="1.0" encoding="utf-8"?>
+<c:chartSpace xmlns:c="http://schemas.openxmlformats.org/drawingml/2006/chart" xmlns:a="http://schemas.openxmlformats.org/drawingml/2006/main" xmlns:r="http://schemas.openxmlformats.org/officeDocument/2006/relationships">
+  <c:date1904 val="0"/>
+  <c:roundedCorners val="1"/>
+  <c:chart>
+    <c:title>
+      <c:tx>
+        <c:rich>
+          <a:bodyPr/>
+          <a:lstStyle/>
+          <a:p>
+            <a:pPr>
+              <a:defRPr sz="1300" b="0" i="0" u="none" strike="noStrike">
+                <a:solidFill>
+                  <a:srgbClr val="12263A"/>
+                </a:solidFill>
+                <a:latin typeface="+mn-lt"/>
+              </a:defRPr>
+            </a:pPr>
+            <a:r>
+              <a:rPr sz="1300" b="0" i="0" u="none" strike="noStrike">
+                <a:solidFill>
+                  <a:srgbClr val="12263A"/>
+                </a:solidFill>
+                <a:latin typeface="+mn-lt"/>
+              </a:rPr>
+              <a:t>SLO attainment per 15 s window (%), repetition 1</a:t>
+            </a:r>
+          </a:p>
+        </c:rich>
+      </c:tx>
+      <c:layout/>
+      <c:overlay val="0"/>
+    </c:title>
+    <c:autoTitleDeleted val="0"/>
+    <c:plotArea>
+      <c:layout/>
+      <c:lineChart>
+        <c:varyColors val="0"/>
+        <c:ser>
+          <c:idx val="0"/>
+          <c:order val="0"/>
+          <c:tx>
+            <c:strRef>
+              <c:f>Sheet1!$B$1</c:f>
+              <c:strCache>
+                <c:ptCount val="1"/>
+                <c:pt idx="0">
+                  <c:v>B0 No bursting</c:v>
+                </c:pt>
+              </c:strCache>
+            </c:strRef>
+          </c:tx>
+          <c:spPr>
+            <a:solidFill>
+              <a:srgbClr val="5B6675"/>
+            </a:solidFill>
+            <a:ln w="25400" cap="flat">
+              <a:solidFill>
+                <a:srgbClr val="5B6675"/>
+              </a:solidFill>
+              <a:prstDash val="solid"/>
+              <a:round/>
+            </a:ln>
+            <a:effectLst/>
+          </c:spPr>
+          <c:invertIfNegative val="0"/>
+          <c:dLbls>
+            <c:numFmt formatCode="#,##0" sourceLinked="0"/>
+            <c:txPr>
+              <a:bodyPr/>
+              <a:lstStyle/>
+              <a:p>
+                <a:pPr>
+                  <a:defRPr b="0" i="0" strike="noStrike" sz="1000" u="none">
+                    <a:solidFill>
+                      <a:srgbClr val="1B2430"/>
+                    </a:solidFill>
+                    <a:latin typeface="+mn-lt"/>
+                  </a:defRPr>
+                </a:pPr>
+              </a:p>
+            </c:txPr>
+            <c:showLegendKey val="0"/>
+            <c:showVal val="0"/>
+            <c:showCatName val="0"/>
+            <c:showSerName val="0"/>
+            <c:showPercent val="0"/>
+            <c:showBubbleSize val="0"/>
+            <c:showLeaderLines val="0"/>
+          </c:dLbls>
+          <c:marker>
+            <c:symbol val="none"/>
+            <c:size val="6"/>
+            <c:spPr>
+              <a:solidFill>
+                <a:srgbClr val="5B6675"/>
+              </a:solidFill>
+              <a:ln w="9525" cap="flat">
+                <a:solidFill>
+                  <a:srgbClr val="5B6675"/>
+                </a:solidFill>
+                <a:prstDash val="solid"/>
+                <a:round/>
+              </a:ln>
+              <a:effectLst/>
+            </c:spPr>
+          </c:marker>
+          <c:cat>
+            <c:multiLvlStrRef>
+              <c:f>Sheet1!$A$2:$A$34</c:f>
+              <c:multiLvlStrCache>
+                <c:ptCount val="33"/>
+                <c:lvl>
+                  <c:pt idx="0">
+                    <c:v>0.0</c:v>
+                  </c:pt>
+                  <c:pt idx="1">
+                    <c:v>0.3</c:v>
+                  </c:pt>
+                  <c:pt idx="2">
+                    <c:v>0.5</c:v>
+                  </c:pt>
+                  <c:pt idx="3">
+                    <c:v>0.8</c:v>
+                  </c:pt>
+                  <c:pt idx="4">
+                    <c:v>1.0</c:v>
+                  </c:pt>
+                  <c:pt idx="5">
+                    <c:v>1.3</c:v>
+                  </c:pt>
+                  <c:pt idx="6">
+                    <c:v>1.5</c:v>
+                  </c:pt>
+                  <c:pt idx="7">
+                    <c:v>1.8</c:v>
+                  </c:pt>
+                  <c:pt idx="8">
+                    <c:v>2.0</c:v>
+                  </c:pt>
+                  <c:pt idx="9">
+                    <c:v>2.3</c:v>
+                  </c:pt>
+                  <c:pt idx="10">
+                    <c:v>2.5</c:v>
+                  </c:pt>
+                  <c:pt idx="11">
+                    <c:v>2.8</c:v>
+                  </c:pt>
+                  <c:pt idx="12">
+                    <c:v>3.0</c:v>
+                  </c:pt>
+                  <c:pt idx="13">
+                    <c:v>3.3</c:v>
+                  </c:pt>
+                  <c:pt idx="14">
+                    <c:v>3.5</c:v>
+                  </c:pt>
+                  <c:pt idx="15">
+                    <c:v>3.8</c:v>
+                  </c:pt>
+                  <c:pt idx="16">
+                    <c:v>4.0</c:v>
+                  </c:pt>
+                  <c:pt idx="17">
+                    <c:v>4.3</c:v>
+                  </c:pt>
+                  <c:pt idx="18">
+                    <c:v>4.5</c:v>
+                  </c:pt>
+                  <c:pt idx="19">
+                    <c:v>4.8</c:v>
+                  </c:pt>
+                  <c:pt idx="20">
+                    <c:v>5.0</c:v>
+                  </c:pt>
+                  <c:pt idx="21">
+                    <c:v>5.3</c:v>
+                  </c:pt>
+                  <c:pt idx="22">
+                    <c:v>5.5</c:v>
+                  </c:pt>
+                  <c:pt idx="23">
+                    <c:v>5.8</c:v>
+                  </c:pt>
+                  <c:pt idx="24">
+                    <c:v>6.0</c:v>
+                  </c:pt>
+                  <c:pt idx="25">
+                    <c:v>6.3</c:v>
+                  </c:pt>
+                  <c:pt idx="26">
+                    <c:v>6.5</c:v>
+                  </c:pt>
+                  <c:pt idx="27">
+                    <c:v>6.8</c:v>
+                  </c:pt>
+                  <c:pt idx="28">
+                    <c:v>7.0</c:v>
+                  </c:pt>
+                  <c:pt idx="29">
+                    <c:v>7.3</c:v>
+                  </c:pt>
+                  <c:pt idx="30">
+                    <c:v>7.5</c:v>
+                  </c:pt>
+                  <c:pt idx="31">
+                    <c:v>7.8</c:v>
+                  </c:pt>
+                  <c:pt idx="32">
+                    <c:v>8.0</c:v>
+                  </c:pt>
+                </c:lvl>
+              </c:multiLvlStrCache>
+            </c:multiLvlStrRef>
+          </c:cat>
+          <c:val>
+            <c:numRef>
+              <c:f>Sheet1!$B$2:$B$34</c:f>
+              <c:numCache>
+                <c:formatCode>General</c:formatCode>
+                <c:ptCount val="33"/>
+                <c:pt idx="0">
+                  <c:v>88.44</c:v>
+                </c:pt>
+                <c:pt idx="1">
+                  <c:v>97.62</c:v>
+                </c:pt>
+                <c:pt idx="2">
+                  <c:v>99.72</c:v>
+                </c:pt>
+                <c:pt idx="3">
+                  <c:v>100</c:v>
+                </c:pt>
+                <c:pt idx="4">
+                  <c:v>100</c:v>
+                </c:pt>
+                <c:pt idx="5">
+                  <c:v>100</c:v>
+                </c:pt>
+                <c:pt idx="6">
+                  <c:v>100</c:v>
+                </c:pt>
+                <c:pt idx="7">
+                  <c:v>100</c:v>
+                </c:pt>
+                <c:pt idx="8">
+                  <c:v>39.2</c:v>
+                </c:pt>
+                <c:pt idx="9">
+                  <c:v>54.34</c:v>
+                </c:pt>
+                <c:pt idx="10">
+                  <c:v>54.52</c:v>
+                </c:pt>
+                <c:pt idx="11">
+                  <c:v>51.08</c:v>
+                </c:pt>
+                <c:pt idx="12">
+                  <c:v>52.35</c:v>
+                </c:pt>
+                <c:pt idx="13">
+                  <c:v>43.1</c:v>
+                </c:pt>
+                <c:pt idx="14">
+                  <c:v>46.82</c:v>
+                </c:pt>
+                <c:pt idx="15">
+                  <c:v>59.19</c:v>
+                </c:pt>
+                <c:pt idx="16">
+                  <c:v>53.15</c:v>
+                </c:pt>
+                <c:pt idx="17">
+                  <c:v>52.31</c:v>
+                </c:pt>
+                <c:pt idx="18">
+                  <c:v>52.86</c:v>
+                </c:pt>
+                <c:pt idx="19">
+                  <c:v>52.61</c:v>
+                </c:pt>
+                <c:pt idx="20">
+                  <c:v>80.25</c:v>
+                </c:pt>
+                <c:pt idx="21">
+                  <c:v>100</c:v>
+                </c:pt>
+                <c:pt idx="22">
+                  <c:v>100</c:v>
+                </c:pt>
+                <c:pt idx="23">
+                  <c:v>100</c:v>
+                </c:pt>
+                <c:pt idx="24">
+                  <c:v>100</c:v>
+                </c:pt>
+                <c:pt idx="25">
+                  <c:v>100</c:v>
+                </c:pt>
+                <c:pt idx="26">
+                  <c:v>100</c:v>
+                </c:pt>
+                <c:pt idx="27">
+                  <c:v>100</c:v>
+                </c:pt>
+                <c:pt idx="28">
+                  <c:v>100</c:v>
+                </c:pt>
+                <c:pt idx="29">
+                  <c:v>100</c:v>
+                </c:pt>
+                <c:pt idx="30">
+                  <c:v>100</c:v>
+                </c:pt>
+                <c:pt idx="31">
+                  <c:v>100</c:v>
+                </c:pt>
+                <c:pt idx="32">
+                  <c:v>100</c:v>
+                </c:pt>
+              </c:numCache>
+            </c:numRef>
+          </c:val>
+          <c:smooth val="0"/>
+        </c:ser>
+        <c:ser>
+          <c:idx val="1"/>
+          <c:order val="1"/>
+          <c:tx>
+            <c:strRef>
+              <c:f>Sheet1!$C$1</c:f>
+              <c:strCache>
+                <c:ptCount val="1"/>
+                <c:pt idx="0">
+                  <c:v>B1 Threshold-only</c:v>
+                </c:pt>
+              </c:strCache>
+            </c:strRef>
+          </c:tx>
+          <c:spPr>
+            <a:solidFill>
+              <a:srgbClr val="E9A23B"/>
+            </a:solidFill>
+            <a:ln w="25400" cap="flat">
+              <a:solidFill>
+                <a:srgbClr val="E9A23B"/>
+              </a:solidFill>
+              <a:prstDash val="solid"/>
+              <a:round/>
+            </a:ln>
+            <a:effectLst/>
+          </c:spPr>
+          <c:invertIfNegative val="0"/>
+          <c:dLbls>
+            <c:numFmt formatCode="#,##0" sourceLinked="0"/>
+            <c:txPr>
+              <a:bodyPr/>
+              <a:lstStyle/>
+              <a:p>
+                <a:pPr>
+                  <a:defRPr b="0" i="0" strike="noStrike" sz="1000" u="none">
+                    <a:solidFill>
+                      <a:srgbClr val="1B2430"/>
+                    </a:solidFill>
+                    <a:latin typeface="+mn-lt"/>
+                  </a:defRPr>
+                </a:pPr>
+              </a:p>
+            </c:txPr>
+            <c:showLegendKey val="0"/>
+            <c:showVal val="0"/>
+            <c:showCatName val="0"/>
+            <c:showSerName val="0"/>
+            <c:showPercent val="0"/>
+            <c:showBubbleSize val="0"/>
+            <c:showLeaderLines val="0"/>
+          </c:dLbls>
+          <c:marker>
+            <c:symbol val="none"/>
+            <c:size val="6"/>
+            <c:spPr>
+              <a:solidFill>
+                <a:srgbClr val="E9A23B"/>
+              </a:solidFill>
+              <a:ln w="9525" cap="flat">
+                <a:solidFill>
+                  <a:srgbClr val="E9A23B"/>
+                </a:solidFill>
+                <a:prstDash val="solid"/>
+                <a:round/>
+              </a:ln>
+              <a:effectLst/>
+            </c:spPr>
+          </c:marker>
+          <c:cat>
+            <c:multiLvlStrRef>
+              <c:f>Sheet1!$A$2:$A$34</c:f>
+              <c:multiLvlStrCache>
+                <c:ptCount val="33"/>
+                <c:lvl>
+                  <c:pt idx="0">
+                    <c:v>0.0</c:v>
+                  </c:pt>
+                  <c:pt idx="1">
+                    <c:v>0.3</c:v>
+                  </c:pt>
+                  <c:pt idx="2">
+                    <c:v>0.5</c:v>
+                  </c:pt>
+                  <c:pt idx="3">
+                    <c:v>0.8</c:v>
+                  </c:pt>
+                  <c:pt idx="4">
+                    <c:v>1.0</c:v>
+                  </c:pt>
+                  <c:pt idx="5">
+                    <c:v>1.3</c:v>
+                  </c:pt>
+                  <c:pt idx="6">
+                    <c:v>1.5</c:v>
+                  </c:pt>
+                  <c:pt idx="7">
+                    <c:v>1.8</c:v>
+                  </c:pt>
+                  <c:pt idx="8">
+                    <c:v>2.0</c:v>
+                  </c:pt>
+                  <c:pt idx="9">
+                    <c:v>2.3</c:v>
+                  </c:pt>
+                  <c:pt idx="10">
+                    <c:v>2.5</c:v>
+                  </c:pt>
+                  <c:pt idx="11">
+                    <c:v>2.8</c:v>
+                  </c:pt>
+                  <c:pt idx="12">
+                    <c:v>3.0</c:v>
+                  </c:pt>
+                  <c:pt idx="13">
+                    <c:v>3.3</c:v>
+                  </c:pt>
+                  <c:pt idx="14">
+                    <c:v>3.5</c:v>
+                  </c:pt>
+                  <c:pt idx="15">
+                    <c:v>3.8</c:v>
+                  </c:pt>
+                  <c:pt idx="16">
+                    <c:v>4.0</c:v>
+                  </c:pt>
+                  <c:pt idx="17">
+                    <c:v>4.3</c:v>
+                  </c:pt>
+                  <c:pt idx="18">
+                    <c:v>4.5</c:v>
+                  </c:pt>
+                  <c:pt idx="19">
+                    <c:v>4.8</c:v>
+                  </c:pt>
+                  <c:pt idx="20">
+                    <c:v>5.0</c:v>
+                  </c:pt>
+                  <c:pt idx="21">
+                    <c:v>5.3</c:v>
+                  </c:pt>
+                  <c:pt idx="22">
+                    <c:v>5.5</c:v>
+                  </c:pt>
+                  <c:pt idx="23">
+                    <c:v>5.8</c:v>
+                  </c:pt>
+                  <c:pt idx="24">
+                    <c:v>6.0</c:v>
+                  </c:pt>
+                  <c:pt idx="25">
+                    <c:v>6.3</c:v>
+                  </c:pt>
+                  <c:pt idx="26">
+                    <c:v>6.5</c:v>
+                  </c:pt>
+                  <c:pt idx="27">
+                    <c:v>6.8</c:v>
+                  </c:pt>
+                  <c:pt idx="28">
+                    <c:v>7.0</c:v>
+                  </c:pt>
+                  <c:pt idx="29">
+                    <c:v>7.3</c:v>
+                  </c:pt>
+                  <c:pt idx="30">
+                    <c:v>7.5</c:v>
+                  </c:pt>
+                  <c:pt idx="31">
+                    <c:v>7.8</c:v>
+                  </c:pt>
+                  <c:pt idx="32">
+                    <c:v>8.0</c:v>
+                  </c:pt>
+                </c:lvl>
+              </c:multiLvlStrCache>
+            </c:multiLvlStrRef>
+          </c:cat>
+          <c:val>
+            <c:numRef>
+              <c:f>Sheet1!$C$2:$C$34</c:f>
+              <c:numCache>
+                <c:formatCode>General</c:formatCode>
+                <c:ptCount val="33"/>
+                <c:pt idx="0">
+                  <c:v>92.5</c:v>
+                </c:pt>
+                <c:pt idx="1">
+                  <c:v>100</c:v>
+                </c:pt>
+                <c:pt idx="2">
+                  <c:v>100</c:v>
+                </c:pt>
+                <c:pt idx="3">
+                  <c:v>100</c:v>
+                </c:pt>
+                <c:pt idx="4">
+                  <c:v>100</c:v>
+                </c:pt>
+                <c:pt idx="5">
+                  <c:v>100</c:v>
+                </c:pt>
+                <c:pt idx="6">
+                  <c:v>100</c:v>
+                </c:pt>
+                <c:pt idx="7">
+                  <c:v>100</c:v>
+                </c:pt>
+                <c:pt idx="8">
+                  <c:v>68.18</c:v>
+                </c:pt>
+                <c:pt idx="9">
+                  <c:v>77.42</c:v>
+                </c:pt>
+                <c:pt idx="10">
+                  <c:v>81.59</c:v>
+                </c:pt>
+                <c:pt idx="11">
+                  <c:v>97.28</c:v>
+                </c:pt>
+                <c:pt idx="12">
+                  <c:v>98.14</c:v>
+                </c:pt>
+                <c:pt idx="13">
+                  <c:v>99.08</c:v>
+                </c:pt>
+                <c:pt idx="14">
+                  <c:v>99.19</c:v>
+                </c:pt>
+                <c:pt idx="15">
+                  <c:v>98.19</c:v>
+                </c:pt>
+                <c:pt idx="16">
+                  <c:v>99.11</c:v>
+                </c:pt>
+                <c:pt idx="17">
+                  <c:v>98.58</c:v>
+                </c:pt>
+                <c:pt idx="18">
+                  <c:v>98.92</c:v>
+                </c:pt>
+                <c:pt idx="19">
+                  <c:v>98.78</c:v>
+                </c:pt>
+                <c:pt idx="20">
+                  <c:v>99.53</c:v>
+                </c:pt>
+                <c:pt idx="21">
+                  <c:v>100</c:v>
+                </c:pt>
+                <c:pt idx="22">
+                  <c:v>100</c:v>
+                </c:pt>
+                <c:pt idx="23">
+                  <c:v>100</c:v>
+                </c:pt>
+                <c:pt idx="24">
+                  <c:v>100</c:v>
+                </c:pt>
+                <c:pt idx="25">
+                  <c:v>100</c:v>
+                </c:pt>
+                <c:pt idx="26">
+                  <c:v>100</c:v>
+                </c:pt>
+                <c:pt idx="27">
+                  <c:v>100</c:v>
+                </c:pt>
+                <c:pt idx="28">
+                  <c:v>100</c:v>
+                </c:pt>
+                <c:pt idx="29">
+                  <c:v>100</c:v>
+                </c:pt>
+                <c:pt idx="30">
+                  <c:v>100</c:v>
+                </c:pt>
+                <c:pt idx="31">
+                  <c:v>100</c:v>
+                </c:pt>
+                <c:pt idx="32">
+                  <c:v>100</c:v>
+                </c:pt>
+              </c:numCache>
+            </c:numRef>
+          </c:val>
+          <c:smooth val="0"/>
+        </c:ser>
+        <c:dLbls>
+          <c:numFmt formatCode="#,##0" sourceLinked="0"/>
+          <c:txPr>
+            <a:bodyPr/>
+            <a:lstStyle/>
+            <a:p>
+              <a:pPr>
+                <a:defRPr b="0" i="0" strike="noStrike" sz="1000" u="none">
+                  <a:solidFill>
+                    <a:srgbClr val="1B2430"/>
+                  </a:solidFill>
+                  <a:latin typeface="+mn-lt"/>
+                </a:defRPr>
+              </a:pPr>
+            </a:p>
+          </c:txPr>
+          <c:showLegendKey val="0"/>
+          <c:showVal val="0"/>
+          <c:showCatName val="0"/>
+          <c:showSerName val="0"/>
+          <c:showPercent val="0"/>
+          <c:showBubbleSize val="0"/>
+          <c:showLeaderLines val="0"/>
+        </c:dLbls>
+        <c:marker val="1"/>
+        <c:axId val="2094734554"/>
+        <c:axId val="2094734552"/>
+        <c:axId val="2094734556"/>
+      </c:lineChart>
+      <c:catAx>
+        <c:axId val="2094734554"/>
+        <c:scaling>
+          <c:orientation val="minMax"/>
+        </c:scaling>
+        <c:delete val="0"/>
+        <c:axPos val="b"/>
+        <c:title>
+          <c:tx>
+            <c:rich>
+              <a:bodyPr/>
+              <a:lstStyle/>
+              <a:p>
+                <a:pPr>
+                  <a:defRPr sz="1100" b="0" i="0" u="none" strike="noStrike">
+                    <a:solidFill>
+                      <a:srgbClr val="5B6675"/>
+                    </a:solidFill>
+                    <a:latin typeface="+mn-lt"/>
+                  </a:defRPr>
+                </a:pPr>
+                <a:r>
+                  <a:rPr sz="1100" b="0" i="0" u="none" strike="noStrike">
+                    <a:solidFill>
+                      <a:srgbClr val="5B6675"/>
+                    </a:solidFill>
+                    <a:latin typeface="+mn-lt"/>
+                  </a:rPr>
+                  <a:t>Minutes into run (burst from 2.0 to 5.0)</a:t>
+                </a:r>
+              </a:p>
+            </c:rich>
+          </c:tx>
+          <c:layout/>
+          <c:overlay val="0"/>
+        </c:title>
+        <c:numFmt formatCode="General" sourceLinked="1"/>
+        <c:majorTickMark val="out"/>
+        <c:minorTickMark val="none"/>
+        <c:tickLblPos val="low"/>
+        <c:spPr>
+          <a:ln w="12700" cap="flat">
+            <a:solidFill>
+              <a:srgbClr val="888888"/>
+            </a:solidFill>
+            <a:prstDash val="solid"/>
+            <a:round/>
+          </a:ln>
+        </c:spPr>
+        <c:txPr>
+          <a:bodyPr/>
+          <a:lstStyle/>
+          <a:p>
+            <a:pPr>
+              <a:defRPr sz="1100" b="0" i="0" u="none" strike="noStrike">
+                <a:solidFill>
+                  <a:srgbClr val="5B6675"/>
+                </a:solidFill>
+                <a:latin typeface="+mn-lt"/>
+              </a:defRPr>
+            </a:pPr>
+            <a:endParaRPr lang="en-US"/>
+          </a:p>
+        </c:txPr>
+        <c:crossAx val="2094734552"/>
+        <c:crosses val="autoZero"/>
+        <c:auto val="1"/>
+        <c:lblAlgn val="ctr"/>
+        <c:noMultiLvlLbl val="1"/>
+        <c:tickLblSkip val="4"/>
+      </c:catAx>
+      <c:valAx>
+        <c:axId val="2094734552"/>
+        <c:scaling>
+          <c:orientation val="minMax"/>
+          <c:max val="100"/>
+          <c:min val="0"/>
+        </c:scaling>
+        <c:delete val="0"/>
+        <c:axPos val="l"/>
+        <c:majorGridlines>
+          <c:spPr>
+            <a:ln w="9525" cap="flat">
+              <a:solidFill>
+                <a:srgbClr val="E3E8ED"/>
+              </a:solidFill>
+              <a:prstDash val="solid"/>
+              <a:round/>
+            </a:ln>
+          </c:spPr>
+        </c:majorGridlines>
+        <c:numFmt formatCode="General" sourceLinked="0"/>
+        <c:majorTickMark val="out"/>
+        <c:minorTickMark val="none"/>
+        <c:tickLblPos val="nextTo"/>
+        <c:spPr>
+          <a:ln w="12700" cap="flat">
+            <a:solidFill>
+              <a:srgbClr val="888888"/>
+            </a:solidFill>
+            <a:prstDash val="solid"/>
+            <a:round/>
+          </a:ln>
+        </c:spPr>
+        <c:txPr>
+          <a:bodyPr/>
+          <a:lstStyle/>
+          <a:p>
+            <a:pPr>
+              <a:defRPr sz="1100" b="0" i="0" u="none" strike="noStrike">
+                <a:solidFill>
+                  <a:srgbClr val="5B6675"/>
+                </a:solidFill>
+                <a:latin typeface="+mn-lt"/>
+              </a:defRPr>
+            </a:pPr>
+            <a:endParaRPr lang="en-US"/>
+          </a:p>
+        </c:txPr>
+        <c:crossAx val="2094734554"/>
+        <c:crosses val="autoZero"/>
+        <c:crossBetween val="between"/>
+      </c:valAx>
+      <c:spPr>
+        <a:noFill/>
+        <a:ln>
+          <a:noFill/>
+        </a:ln>
+        <a:effectLst/>
+      </c:spPr>
+    </c:plotArea>
+    <c:legend>
+      <c:legendPos val="b"/>
+      <c:overlay val="0"/>
+      <c:txPr>
+        <a:bodyPr/>
+        <a:lstStyle/>
+        <a:p>
+          <a:pPr>
+            <a:defRPr sz="1100">
+              <a:solidFill>
+                <a:srgbClr val="1B2430"/>
+              </a:solidFill>
+              <a:latin typeface="+mn-lt"/>
+              <a:cs typeface="+mn-lt"/>
+            </a:defRPr>
+          </a:pPr>
+          <a:endParaRPr lang="en-US"/>
+        </a:p>
+      </c:txPr>
+    </c:legend>
+    <c:plotVisOnly val="1"/>
+    <c:dispBlanksAs val="span"/>
+  </c:chart>
+  <c:spPr>
+    <a:noFill/>
+    <a:ln>
+      <a:noFill/>
+    </a:ln>
+    <a:effectLst/>
+  </c:spPr>
+  <c:externalData r:id="rId1">
+    <c:autoUpdate val="0"/>
+  </c:externalData>
+</c:chartSpace>
+</file>
+
 <file path=ppt/notesMasters/notesMaster1.xml><?xml version="1.0" encoding="utf-8"?>
 <p:notesMaster xmlns:a="http://schemas.openxmlformats.org/drawingml/2006/main" xmlns:r="http://schemas.openxmlformats.org/officeDocument/2006/relationships" xmlns:p="http://schemas.openxmlformats.org/presentationml/2006/main">
   <p:cSld>
@@ -1237,7 +2048,7 @@
           <a:p>
             <a:r>
               <a:rPr lang="en-US" dirty="0"/>
-              <a:t>Replace the two frames with real screenshots before the review. Timestamps and hostnames make it obvious the environment is ours and live.</a:t>
+              <a:t>These are copies of real terminal output saved by deploy/k3s/05-evidence.sh. The two foreign-region nodes show the added netem delay in their round-trip times.</a:t>
             </a:r>
             <a:endParaRPr lang="en-US" dirty="0"/>
           </a:p>
@@ -1413,7 +2224,7 @@
           <a:p>
             <a:r>
               <a:rPr lang="en-US" dirty="0"/>
-              <a:t>Fill this table from the actual baseline runs before the review. The rubric only credits a baseline that runs and produces numbers.</a:t>
+              <a:t>Raw data: results/testbed/runs/&lt;config&gt;_m2_d180_s0.3_r&lt;rep&gt;/ (events.jsonl, summary.json). Requests are logged per Locust process.</a:t>
             </a:r>
             <a:endParaRPr lang="en-US" dirty="0"/>
           </a:p>
@@ -2381,7 +3192,7 @@
           <a:p>
             <a:r>
               <a:rPr lang="en-US" dirty="0"/>
-              <a:t>Free-tier options: Oracle Cloud Always Free (Hyderabad/Mumbai) or AWS free tier in ap-south-1. A second public destination outside India is emulated with tc netem delay plus a non-IN region label, since a second paid region is out of budget — we state this as a threat to validity.</a:t>
+              <a:t>Every node is a real k3s node; the public pool runs on the same host, with region labels, taints and netem WAN delay. The repo also has deploy/k3s scripts that join real free-tier VMs over Tailscale with the same labels — that is the planned final-review upgrade, listed as a threat to validity.</a:t>
             </a:r>
             <a:endParaRPr lang="en-US" dirty="0"/>
           </a:p>
@@ -3432,7 +4243,7 @@
                   <a:srgbClr val="4C6A92"/>
                 </a:solidFill>
               </a:rPr>
-              <a:t>Rubric: a screenshot or log proving it runs — slides alone score 0</a:t>
+              <a:t>Captured on DEATHSTAR at 2026-10-25 23:55:01 UTC · raw output in evidence/20261025-235501/</a:t>
             </a:r>
             <a:endParaRPr lang="en-US" sz="1600" dirty="0"/>
           </a:p>
@@ -3440,104 +4251,14 @@
       </p:sp>
       <p:sp>
         <p:nvSpPr>
-          <p:cNvPr id="4" name="Shape 2"/>
-          <p:cNvSpPr/>
+          <p:cNvPr id="4" name="Text 2"/>
+          <p:cNvSpPr txBox="1"/>
           <p:nvPr/>
         </p:nvSpPr>
         <p:spPr>
           <a:xfrm>
-            <a:off x="548640" y="1645920"/>
-            <a:ext cx="5394960" cy="3520440"/>
-          </a:xfrm>
-          <a:prstGeom prst="roundRect">
-            <a:avLst>
-              <a:gd name="adj" fmla="val 2078"/>
-            </a:avLst>
-          </a:prstGeom>
-          <a:solidFill>
-            <a:srgbClr val="EEF3F6"/>
-          </a:solidFill>
-          <a:ln w="9525">
-            <a:solidFill>
-              <a:srgbClr val="C9D3DC"/>
-            </a:solidFill>
-            <a:prstDash val="dash"/>
-          </a:ln>
-        </p:spPr>
-      </p:sp>
-      <p:sp>
-        <p:nvSpPr>
-          <p:cNvPr id="5" name="Shape 3"/>
-          <p:cNvSpPr/>
-          <p:nvPr/>
-        </p:nvSpPr>
-        <p:spPr>
-          <a:xfrm>
-            <a:off x="731520" y="1783080"/>
-            <a:ext cx="3291840" cy="292608"/>
-          </a:xfrm>
-          <a:prstGeom prst="roundRect">
-            <a:avLst>
-              <a:gd name="adj" fmla="val 25000"/>
-            </a:avLst>
-          </a:prstGeom>
-          <a:solidFill>
-            <a:srgbClr val="D1495B"/>
-          </a:solidFill>
-          <a:ln w="12700">
-            <a:solidFill>
-              <a:srgbClr val="D1495B"/>
-            </a:solidFill>
-            <a:prstDash val="solid"/>
-          </a:ln>
-        </p:spPr>
-      </p:sp>
-      <p:sp>
-        <p:nvSpPr>
-          <p:cNvPr id="6" name="Text 4"/>
-          <p:cNvSpPr txBox="1"/>
-          <p:nvPr/>
-        </p:nvSpPr>
-        <p:spPr>
-          <a:xfrm>
-            <a:off x="731520" y="1783080"/>
-            <a:ext cx="3291840" cy="292608"/>
-          </a:xfrm>
-          <a:prstGeom prst="rect">
-            <a:avLst/>
-          </a:prstGeom>
-          <a:noFill/>
-          <a:ln/>
-        </p:spPr>
-        <p:txBody>
-          <a:bodyPr wrap="square" lIns="0" tIns="0" rIns="0" bIns="0" rtlCol="0" anchor="ctr"/>
-          <a:lstStyle/>
-          <a:p>
-            <a:pPr algn="ctr" indent="0" marL="0">
-              <a:buNone/>
-            </a:pPr>
-            <a:r>
-              <a:rPr lang="en-US" sz="1000" b="1" dirty="0">
-                <a:solidFill>
-                  <a:srgbClr val="FFFFFF"/>
-                </a:solidFill>
-              </a:rPr>
-              <a:t>INSERT SCREENSHOT FROM YOUR TESTBED</a:t>
-            </a:r>
-            <a:endParaRPr lang="en-US" sz="1000" dirty="0"/>
-          </a:p>
-        </p:txBody>
-      </p:sp>
-      <p:sp>
-        <p:nvSpPr>
-          <p:cNvPr id="7" name="Text 5"/>
-          <p:cNvSpPr txBox="1"/>
-          <p:nvPr/>
-        </p:nvSpPr>
-        <p:spPr>
-          <a:xfrm>
-            <a:off x="822960" y="2286000"/>
-            <a:ext cx="4846320" cy="731520"/>
+            <a:off x="548640" y="1600200"/>
+            <a:ext cx="11064240" cy="320040"/>
           </a:xfrm>
           <a:prstGeom prst="rect">
             <a:avLst/>
@@ -3553,31 +4274,31 @@
               <a:buNone/>
             </a:pPr>
             <a:r>
-              <a:rPr lang="en-US" sz="1400" dirty="0">
+              <a:rPr lang="en-US" sz="1500" b="1" dirty="0">
                 <a:solidFill>
-                  <a:srgbClr val="5B6675"/>
+                  <a:srgbClr val="12263A"/>
                 </a:solidFill>
               </a:rPr>
-              <a:t>Private server + agents and the public node(s) all Ready, with region labels</a:t>
+              <a:t>Nodes, with destination and region labels</a:t>
             </a:r>
-            <a:endParaRPr lang="en-US" sz="1400" dirty="0"/>
+            <a:endParaRPr lang="en-US" sz="1500" dirty="0"/>
           </a:p>
         </p:txBody>
       </p:sp>
       <p:sp>
         <p:nvSpPr>
-          <p:cNvPr id="8" name="Shape 6"/>
+          <p:cNvPr id="5" name="Shape 3"/>
           <p:cNvSpPr/>
           <p:nvPr/>
         </p:nvSpPr>
         <p:spPr>
           <a:xfrm>
-            <a:off x="822960" y="3154680"/>
-            <a:ext cx="4846320" cy="548640"/>
+            <a:off x="548640" y="1965960"/>
+            <a:ext cx="11064240" cy="1691640"/>
           </a:xfrm>
           <a:prstGeom prst="roundRect">
             <a:avLst>
-              <a:gd name="adj" fmla="val 13333"/>
+              <a:gd name="adj" fmla="val 4324"/>
             </a:avLst>
           </a:prstGeom>
           <a:solidFill>
@@ -3593,14 +4314,14 @@
       </p:sp>
       <p:sp>
         <p:nvSpPr>
-          <p:cNvPr id="9" name="Text 7"/>
+          <p:cNvPr id="6" name="Text 4"/>
           <p:cNvSpPr txBox="1"/>
           <p:nvPr/>
         </p:nvSpPr>
         <p:spPr>
           <a:xfrm>
-            <a:off x="1005840" y="3291840"/>
-            <a:ext cx="4480560" cy="274320"/>
+            <a:off x="731520" y="2103120"/>
+            <a:ext cx="10698480" cy="1417320"/>
           </a:xfrm>
           <a:prstGeom prst="rect">
             <a:avLst/>
@@ -3616,7 +4337,7 @@
               <a:buNone/>
             </a:pPr>
             <a:r>
-              <a:rPr lang="en-US" sz="1300" dirty="0">
+              <a:rPr lang="en-US" sz="1200" dirty="0">
                 <a:solidFill>
                   <a:srgbClr val="E6EDF3"/>
                 </a:solidFill>
@@ -3624,148 +4345,124 @@
                 <a:ea typeface="Courier New" pitchFamily="34" charset="-122"/>
                 <a:cs typeface="Courier New" pitchFamily="34" charset="-120"/>
               </a:rPr>
-              <a:t>$ kubectl get nodes -o wide --show-labels</a:t>
+              <a:t>$ kubectl get nodes -L p11.burst/destination,p11.burst/region</a:t>
             </a:r>
-            <a:endParaRPr lang="en-US" sz="1300" dirty="0"/>
-          </a:p>
-        </p:txBody>
-      </p:sp>
-      <p:sp>
-        <p:nvSpPr>
-          <p:cNvPr id="10" name="Text 8"/>
-          <p:cNvSpPr txBox="1"/>
-          <p:nvPr/>
-        </p:nvSpPr>
-        <p:spPr>
-          <a:xfrm>
-            <a:off x="822960" y="3931920"/>
-            <a:ext cx="4846320" cy="914400"/>
-          </a:xfrm>
-          <a:prstGeom prst="rect">
-            <a:avLst/>
-          </a:prstGeom>
-          <a:noFill/>
-          <a:ln/>
-        </p:spPr>
-        <p:txBody>
-          <a:bodyPr wrap="square" lIns="0" tIns="0" rIns="0" bIns="0" rtlCol="0" anchor="ctr"/>
-          <a:lstStyle/>
-          <a:p>
-            <a:pPr algn="ctr" indent="0" marL="0">
+            <a:endParaRPr lang="en-US" sz="1200" dirty="0"/>
+          </a:p>
+          <a:p>
+            <a:pPr indent="0" marL="0">
               <a:buNone/>
             </a:pPr>
             <a:r>
-              <a:rPr lang="en-US" sz="1200" i="1" dirty="0">
+              <a:rPr lang="en-US" sz="1200" dirty="0">
                 <a:solidFill>
-                  <a:srgbClr val="5B6675"/>
+                  <a:srgbClr val="E6EDF3"/>
                 </a:solidFill>
+                <a:latin typeface="Courier New" pitchFamily="34" charset="0"/>
+                <a:ea typeface="Courier New" pitchFamily="34" charset="-122"/>
+                <a:cs typeface="Courier New" pitchFamily="34" charset="-120"/>
               </a:rPr>
-              <a:t>Paste screenshot here (crop to the terminal, include hostname and timestamp)</a:t>
+              <a:t>NAME               STATUS                     ROLES           AGE     VERSION        DESTINATION   REGION</a:t>
             </a:r>
             <a:endParaRPr lang="en-US" sz="1200" dirty="0"/>
           </a:p>
-        </p:txBody>
-      </p:sp>
-      <p:sp>
-        <p:nvSpPr>
-          <p:cNvPr id="11" name="Shape 9"/>
-          <p:cNvSpPr/>
-          <p:nvPr/>
-        </p:nvSpPr>
-        <p:spPr>
-          <a:xfrm>
-            <a:off x="6217920" y="1645920"/>
-            <a:ext cx="5394960" cy="3520440"/>
-          </a:xfrm>
-          <a:prstGeom prst="roundRect">
-            <a:avLst>
-              <a:gd name="adj" fmla="val 2078"/>
-            </a:avLst>
-          </a:prstGeom>
-          <a:solidFill>
-            <a:srgbClr val="EEF3F6"/>
-          </a:solidFill>
-          <a:ln w="9525">
-            <a:solidFill>
-              <a:srgbClr val="C9D3DC"/>
-            </a:solidFill>
-            <a:prstDash val="dash"/>
-          </a:ln>
-        </p:spPr>
-      </p:sp>
-      <p:sp>
-        <p:nvSpPr>
-          <p:cNvPr id="12" name="Shape 10"/>
-          <p:cNvSpPr/>
-          <p:nvPr/>
-        </p:nvSpPr>
-        <p:spPr>
-          <a:xfrm>
-            <a:off x="6400800" y="1783080"/>
-            <a:ext cx="3291840" cy="292608"/>
-          </a:xfrm>
-          <a:prstGeom prst="roundRect">
-            <a:avLst>
-              <a:gd name="adj" fmla="val 25000"/>
-            </a:avLst>
-          </a:prstGeom>
-          <a:solidFill>
-            <a:srgbClr val="D1495B"/>
-          </a:solidFill>
-          <a:ln w="12700">
-            <a:solidFill>
-              <a:srgbClr val="D1495B"/>
-            </a:solidFill>
-            <a:prstDash val="solid"/>
-          </a:ln>
-        </p:spPr>
-      </p:sp>
-      <p:sp>
-        <p:nvSpPr>
-          <p:cNvPr id="13" name="Text 11"/>
-          <p:cNvSpPr txBox="1"/>
-          <p:nvPr/>
-        </p:nvSpPr>
-        <p:spPr>
-          <a:xfrm>
-            <a:off x="6400800" y="1783080"/>
-            <a:ext cx="3291840" cy="292608"/>
-          </a:xfrm>
-          <a:prstGeom prst="rect">
-            <a:avLst/>
-          </a:prstGeom>
-          <a:noFill/>
-          <a:ln/>
-        </p:spPr>
-        <p:txBody>
-          <a:bodyPr wrap="square" lIns="0" tIns="0" rIns="0" bIns="0" rtlCol="0" anchor="ctr"/>
-          <a:lstStyle/>
-          <a:p>
-            <a:pPr algn="ctr" indent="0" marL="0">
+          <a:p>
+            <a:pPr indent="0" marL="0">
               <a:buNone/>
             </a:pPr>
             <a:r>
-              <a:rPr lang="en-US" sz="1000" b="1" dirty="0">
+              <a:rPr lang="en-US" sz="1200" dirty="0">
                 <a:solidFill>
-                  <a:srgbClr val="FFFFFF"/>
+                  <a:srgbClr val="E6EDF3"/>
                 </a:solidFill>
+                <a:latin typeface="Courier New" pitchFamily="34" charset="0"/>
+                <a:ea typeface="Courier New" pitchFamily="34" charset="-122"/>
+                <a:cs typeface="Courier New" pitchFamily="34" charset="-120"/>
               </a:rPr>
-              <a:t>INSERT SCREENSHOT FROM YOUR TESTBED</a:t>
+              <a:t>k3d-p11-agent-0    Ready                      &lt;none&gt;          3h51m   v1.35.5+k3s1   private       IN</a:t>
             </a:r>
-            <a:endParaRPr lang="en-US" sz="1000" dirty="0"/>
+            <a:endParaRPr lang="en-US" sz="1200" dirty="0"/>
+          </a:p>
+          <a:p>
+            <a:pPr indent="0" marL="0">
+              <a:buNone/>
+            </a:pPr>
+            <a:r>
+              <a:rPr lang="en-US" sz="1200" dirty="0">
+                <a:solidFill>
+                  <a:srgbClr val="E6EDF3"/>
+                </a:solidFill>
+                <a:latin typeface="Courier New" pitchFamily="34" charset="0"/>
+                <a:ea typeface="Courier New" pitchFamily="34" charset="-122"/>
+                <a:cs typeface="Courier New" pitchFamily="34" charset="-120"/>
+              </a:rPr>
+              <a:t>k3d-p11-agent-1    Ready,SchedulingDisabled   &lt;none&gt;          3h51m   v1.35.5+k3s1   pub-in        IN</a:t>
+            </a:r>
+            <a:endParaRPr lang="en-US" sz="1200" dirty="0"/>
+          </a:p>
+          <a:p>
+            <a:pPr indent="0" marL="0">
+              <a:buNone/>
+            </a:pPr>
+            <a:r>
+              <a:rPr lang="en-US" sz="1200" dirty="0">
+                <a:solidFill>
+                  <a:srgbClr val="E6EDF3"/>
+                </a:solidFill>
+                <a:latin typeface="Courier New" pitchFamily="34" charset="0"/>
+                <a:ea typeface="Courier New" pitchFamily="34" charset="-122"/>
+                <a:cs typeface="Courier New" pitchFamily="34" charset="-120"/>
+              </a:rPr>
+              <a:t>k3d-p11-agent-2    Ready,SchedulingDisabled   &lt;none&gt;          3h51m   v1.35.5+k3s1   pub-sg        non-IN</a:t>
+            </a:r>
+            <a:endParaRPr lang="en-US" sz="1200" dirty="0"/>
+          </a:p>
+          <a:p>
+            <a:pPr indent="0" marL="0">
+              <a:buNone/>
+            </a:pPr>
+            <a:r>
+              <a:rPr lang="en-US" sz="1200" dirty="0">
+                <a:solidFill>
+                  <a:srgbClr val="E6EDF3"/>
+                </a:solidFill>
+                <a:latin typeface="Courier New" pitchFamily="34" charset="0"/>
+                <a:ea typeface="Courier New" pitchFamily="34" charset="-122"/>
+                <a:cs typeface="Courier New" pitchFamily="34" charset="-120"/>
+              </a:rPr>
+              <a:t>k3d-p11-agent-3    Ready,SchedulingDisabled   &lt;none&gt;          3h51m   v1.35.5+k3s1   pub-us        non-IN</a:t>
+            </a:r>
+            <a:endParaRPr lang="en-US" sz="1200" dirty="0"/>
+          </a:p>
+          <a:p>
+            <a:pPr indent="0" marL="0">
+              <a:buNone/>
+            </a:pPr>
+            <a:r>
+              <a:rPr lang="en-US" sz="1200" dirty="0">
+                <a:solidFill>
+                  <a:srgbClr val="E6EDF3"/>
+                </a:solidFill>
+                <a:latin typeface="Courier New" pitchFamily="34" charset="0"/>
+                <a:ea typeface="Courier New" pitchFamily="34" charset="-122"/>
+                <a:cs typeface="Courier New" pitchFamily="34" charset="-120"/>
+              </a:rPr>
+              <a:t>k3d-p11-server-0   Ready                      control-plane   3h51m   v1.35.5+k3s1   private       IN</a:t>
+            </a:r>
+            <a:endParaRPr lang="en-US" sz="1200" dirty="0"/>
           </a:p>
         </p:txBody>
       </p:sp>
       <p:sp>
         <p:nvSpPr>
-          <p:cNvPr id="14" name="Text 12"/>
+          <p:cNvPr id="7" name="Text 5"/>
           <p:cNvSpPr txBox="1"/>
           <p:nvPr/>
         </p:nvSpPr>
         <p:spPr>
           <a:xfrm>
-            <a:off x="6492240" y="2286000"/>
-            <a:ext cx="4846320" cy="731520"/>
+            <a:off x="548640" y="3840480"/>
+            <a:ext cx="11064240" cy="320040"/>
           </a:xfrm>
           <a:prstGeom prst="rect">
             <a:avLst/>
@@ -3781,31 +4478,31 @@
               <a:buNone/>
             </a:pPr>
             <a:r>
-              <a:rPr lang="en-US" sz="1400" dirty="0">
+              <a:rPr lang="en-US" sz="1500" b="1" dirty="0">
                 <a:solidFill>
-                  <a:srgbClr val="5B6675"/>
+                  <a:srgbClr val="12263A"/>
                 </a:solidFill>
               </a:rPr>
-              <a:t>App pods on private nodes; Prometheus and controller running</a:t>
+              <a:t>Workload pods (idle) and measured round-trip time to each node</a:t>
             </a:r>
-            <a:endParaRPr lang="en-US" sz="1400" dirty="0"/>
+            <a:endParaRPr lang="en-US" sz="1500" dirty="0"/>
           </a:p>
         </p:txBody>
       </p:sp>
       <p:sp>
         <p:nvSpPr>
-          <p:cNvPr id="15" name="Shape 13"/>
+          <p:cNvPr id="8" name="Shape 6"/>
           <p:cNvSpPr/>
           <p:nvPr/>
         </p:nvSpPr>
         <p:spPr>
           <a:xfrm>
-            <a:off x="6492240" y="3154680"/>
-            <a:ext cx="4846320" cy="548640"/>
+            <a:off x="548640" y="4206240"/>
+            <a:ext cx="6035040" cy="1920240"/>
           </a:xfrm>
           <a:prstGeom prst="roundRect">
             <a:avLst>
-              <a:gd name="adj" fmla="val 13333"/>
+              <a:gd name="adj" fmla="val 3810"/>
             </a:avLst>
           </a:prstGeom>
           <a:solidFill>
@@ -3821,14 +4518,14 @@
       </p:sp>
       <p:sp>
         <p:nvSpPr>
-          <p:cNvPr id="16" name="Text 14"/>
+          <p:cNvPr id="9" name="Text 7"/>
           <p:cNvSpPr txBox="1"/>
           <p:nvPr/>
         </p:nvSpPr>
         <p:spPr>
           <a:xfrm>
-            <a:off x="6675120" y="3291840"/>
-            <a:ext cx="4480560" cy="274320"/>
+            <a:off x="731520" y="4343400"/>
+            <a:ext cx="5669280" cy="1645920"/>
           </a:xfrm>
           <a:prstGeom prst="rect">
             <a:avLst/>
@@ -3844,7 +4541,7 @@
               <a:buNone/>
             </a:pPr>
             <a:r>
-              <a:rPr lang="en-US" sz="1300" dirty="0">
+              <a:rPr lang="en-US" sz="1100" dirty="0">
                 <a:solidFill>
                   <a:srgbClr val="E6EDF3"/>
                 </a:solidFill>
@@ -3852,22 +4549,117 @@
                 <a:ea typeface="Courier New" pitchFamily="34" charset="-122"/>
                 <a:cs typeface="Courier New" pitchFamily="34" charset="-120"/>
               </a:rPr>
-              <a:t>$ kubectl get pods -A -o wide</a:t>
+              <a:t>$ kubectl get pods -n p11-app -o custom-columns=...</a:t>
             </a:r>
-            <a:endParaRPr lang="en-US" sz="1300" dirty="0"/>
+            <a:endParaRPr lang="en-US" sz="1100" dirty="0"/>
+          </a:p>
+          <a:p>
+            <a:pPr indent="0" marL="0">
+              <a:buNone/>
+            </a:pPr>
+            <a:r>
+              <a:rPr lang="en-US" sz="1100" dirty="0">
+                <a:solidFill>
+                  <a:srgbClr val="E6EDF3"/>
+                </a:solidFill>
+                <a:latin typeface="Courier New" pitchFamily="34" charset="0"/>
+                <a:ea typeface="Courier New" pitchFamily="34" charset="-122"/>
+                <a:cs typeface="Courier New" pitchFamily="34" charset="-120"/>
+              </a:rPr>
+              <a:t>POD                       STATUS    NODE               IP</a:t>
+            </a:r>
+            <a:endParaRPr lang="en-US" sz="1100" dirty="0"/>
+          </a:p>
+          <a:p>
+            <a:pPr indent="0" marL="0">
+              <a:buNone/>
+            </a:pPr>
+            <a:r>
+              <a:rPr lang="en-US" sz="1100" dirty="0">
+                <a:solidFill>
+                  <a:srgbClr val="E6EDF3"/>
+                </a:solidFill>
+                <a:latin typeface="Courier New" pitchFamily="34" charset="0"/>
+                <a:ea typeface="Courier New" pitchFamily="34" charset="-122"/>
+                <a:cs typeface="Courier New" pitchFamily="34" charset="-120"/>
+              </a:rPr>
+              <a:t>lms-65bbb485c-h4qr2       Running   k3d-p11-agent-0    10.42.0.110</a:t>
+            </a:r>
+            <a:endParaRPr lang="en-US" sz="1100" dirty="0"/>
+          </a:p>
+          <a:p>
+            <a:pPr indent="0" marL="0">
+              <a:buNone/>
+            </a:pPr>
+            <a:r>
+              <a:rPr lang="en-US" sz="1100" dirty="0">
+                <a:solidFill>
+                  <a:srgbClr val="E6EDF3"/>
+                </a:solidFill>
+                <a:latin typeface="Courier New" pitchFamily="34" charset="0"/>
+                <a:ea typeface="Courier New" pitchFamily="34" charset="-122"/>
+                <a:cs typeface="Courier New" pitchFamily="34" charset="-120"/>
+              </a:rPr>
+              <a:t>records-57cbbc7df-h8wbc   Running   k3d-p11-agent-0    10.42.0.115</a:t>
+            </a:r>
+            <a:endParaRPr lang="en-US" sz="1100" dirty="0"/>
+          </a:p>
+          <a:p>
+            <a:pPr indent="0" marL="0">
+              <a:buNone/>
+            </a:pPr>
+            <a:r>
+              <a:rPr lang="en-US" sz="1100" dirty="0">
+                <a:solidFill>
+                  <a:srgbClr val="E6EDF3"/>
+                </a:solidFill>
+                <a:latin typeface="Courier New" pitchFamily="34" charset="0"/>
+                <a:ea typeface="Courier New" pitchFamily="34" charset="-122"/>
+                <a:cs typeface="Courier New" pitchFamily="34" charset="-120"/>
+              </a:rPr>
+              <a:t>static-598f6bc747-wgss6   Running   k3d-p11-server-0   10.42.3.115</a:t>
+            </a:r>
+            <a:endParaRPr lang="en-US" sz="1100" dirty="0"/>
           </a:p>
         </p:txBody>
       </p:sp>
       <p:sp>
         <p:nvSpPr>
-          <p:cNvPr id="17" name="Text 15"/>
+          <p:cNvPr id="10" name="Shape 8"/>
+          <p:cNvSpPr/>
+          <p:nvPr/>
+        </p:nvSpPr>
+        <p:spPr>
+          <a:xfrm>
+            <a:off x="6766560" y="4206240"/>
+            <a:ext cx="4846320" cy="1920240"/>
+          </a:xfrm>
+          <a:prstGeom prst="roundRect">
+            <a:avLst>
+              <a:gd name="adj" fmla="val 3810"/>
+            </a:avLst>
+          </a:prstGeom>
+          <a:solidFill>
+            <a:srgbClr val="0F1B2A"/>
+          </a:solidFill>
+          <a:ln w="9525">
+            <a:solidFill>
+              <a:srgbClr val="0F1B2A"/>
+            </a:solidFill>
+            <a:prstDash val="solid"/>
+          </a:ln>
+        </p:spPr>
+      </p:sp>
+      <p:sp>
+        <p:nvSpPr>
+          <p:cNvPr id="11" name="Text 9"/>
           <p:cNvSpPr txBox="1"/>
           <p:nvPr/>
         </p:nvSpPr>
         <p:spPr>
           <a:xfrm>
-            <a:off x="6492240" y="3931920"/>
-            <a:ext cx="4846320" cy="914400"/>
+            <a:off x="6949440" y="4343400"/>
+            <a:ext cx="4480560" cy="1645920"/>
           </a:xfrm>
           <a:prstGeom prst="rect">
             <a:avLst/>
@@ -3876,95 +4668,109 @@
           <a:ln/>
         </p:spPr>
         <p:txBody>
-          <a:bodyPr wrap="square" lIns="0" tIns="0" rIns="0" bIns="0" rtlCol="0" anchor="ctr"/>
-          <a:lstStyle/>
-          <a:p>
-            <a:pPr algn="ctr" indent="0" marL="0">
-              <a:buNone/>
-            </a:pPr>
-            <a:r>
-              <a:rPr lang="en-US" sz="1200" i="1" dirty="0">
-                <a:solidFill>
-                  <a:srgbClr val="5B6675"/>
-                </a:solidFill>
-              </a:rPr>
-              <a:t>Paste screenshot here (crop to the terminal, include hostname and timestamp)</a:t>
-            </a:r>
-            <a:endParaRPr lang="en-US" sz="1200" dirty="0"/>
-          </a:p>
-        </p:txBody>
-      </p:sp>
-      <p:sp>
-        <p:nvSpPr>
-          <p:cNvPr id="18" name="Shape 16"/>
-          <p:cNvSpPr/>
-          <p:nvPr/>
-        </p:nvSpPr>
-        <p:spPr>
-          <a:xfrm>
-            <a:off x="548640" y="5349240"/>
-            <a:ext cx="11064240" cy="777240"/>
-          </a:xfrm>
-          <a:prstGeom prst="roundRect">
-            <a:avLst>
-              <a:gd name="adj" fmla="val 9412"/>
-            </a:avLst>
-          </a:prstGeom>
-          <a:solidFill>
-            <a:srgbClr val="DDF1EE"/>
-          </a:solidFill>
-          <a:ln w="9525">
-            <a:solidFill>
-              <a:srgbClr val="DDF1EE"/>
-            </a:solidFill>
-            <a:prstDash val="solid"/>
-          </a:ln>
-        </p:spPr>
-      </p:sp>
-      <p:sp>
-        <p:nvSpPr>
-          <p:cNvPr id="19" name="Text 17"/>
-          <p:cNvSpPr txBox="1"/>
-          <p:nvPr/>
-        </p:nvSpPr>
-        <p:spPr>
-          <a:xfrm>
-            <a:off x="777240" y="5394960"/>
-            <a:ext cx="10607040" cy="685800"/>
-          </a:xfrm>
-          <a:prstGeom prst="rect">
-            <a:avLst/>
-          </a:prstGeom>
-          <a:noFill/>
-          <a:ln/>
-        </p:spPr>
-        <p:txBody>
-          <a:bodyPr wrap="square" lIns="0" tIns="0" rIns="0" bIns="0" rtlCol="0" anchor="ctr"/>
+          <a:bodyPr wrap="square" lIns="0" tIns="0" rIns="0" bIns="0" rtlCol="0" anchor="t"/>
           <a:lstStyle/>
           <a:p>
             <a:pPr indent="0" marL="0">
               <a:buNone/>
             </a:pPr>
             <a:r>
-              <a:rPr lang="en-US" sz="1400" b="1" dirty="0">
+              <a:rPr lang="en-US" sz="1100" dirty="0">
                 <a:solidFill>
-                  <a:srgbClr val="1B2430"/>
+                  <a:srgbClr val="E6EDF3"/>
                 </a:solidFill>
+                <a:latin typeface="Courier New" pitchFamily="34" charset="0"/>
+                <a:ea typeface="Courier New" pitchFamily="34" charset="-122"/>
+                <a:cs typeface="Courier New" pitchFamily="34" charset="-120"/>
               </a:rPr>
-              <a:t>Also attach: </a:t>
+              <a:t>$ ping -c 5 &lt;node-ip&gt;   (avg RTT)</a:t>
             </a:r>
+            <a:endParaRPr lang="en-US" sz="1100" dirty="0"/>
+          </a:p>
+          <a:p>
             <a:pPr indent="0" marL="0">
               <a:buNone/>
             </a:pPr>
             <a:r>
-              <a:rPr lang="en-US" sz="1400" dirty="0">
+              <a:rPr lang="en-US" sz="1100" dirty="0">
                 <a:solidFill>
-                  <a:srgbClr val="1B2430"/>
+                  <a:srgbClr val="E6EDF3"/>
                 </a:solidFill>
+                <a:latin typeface="Courier New" pitchFamily="34" charset="0"/>
+                <a:ea typeface="Courier New" pitchFamily="34" charset="-122"/>
+                <a:cs typeface="Courier New" pitchFamily="34" charset="-120"/>
               </a:rPr>
-              <a:t>k3s agent join log from the public VM · Locust web UI at a burst peak · `kubectl describe node pub-in` showing taints and labels.</a:t>
+              <a:t>k3d-p11-agent-0    172.18.0.5   0.049 ms</a:t>
             </a:r>
-            <a:endParaRPr lang="en-US" sz="1400" dirty="0"/>
+            <a:endParaRPr lang="en-US" sz="1100" dirty="0"/>
+          </a:p>
+          <a:p>
+            <a:pPr indent="0" marL="0">
+              <a:buNone/>
+            </a:pPr>
+            <a:r>
+              <a:rPr lang="en-US" sz="1100" dirty="0">
+                <a:solidFill>
+                  <a:srgbClr val="E6EDF3"/>
+                </a:solidFill>
+                <a:latin typeface="Courier New" pitchFamily="34" charset="0"/>
+                <a:ea typeface="Courier New" pitchFamily="34" charset="-122"/>
+                <a:cs typeface="Courier New" pitchFamily="34" charset="-120"/>
+              </a:rPr>
+              <a:t>k3d-p11-agent-1    172.18.0.3   0.051 ms</a:t>
+            </a:r>
+            <a:endParaRPr lang="en-US" sz="1100" dirty="0"/>
+          </a:p>
+          <a:p>
+            <a:pPr indent="0" marL="0">
+              <a:buNone/>
+            </a:pPr>
+            <a:r>
+              <a:rPr lang="en-US" sz="1100" dirty="0">
+                <a:solidFill>
+                  <a:srgbClr val="E6EDF3"/>
+                </a:solidFill>
+                <a:latin typeface="Courier New" pitchFamily="34" charset="0"/>
+                <a:ea typeface="Courier New" pitchFamily="34" charset="-122"/>
+                <a:cs typeface="Courier New" pitchFamily="34" charset="-120"/>
+              </a:rPr>
+              <a:t>k3d-p11-agent-2    172.18.0.6   37.861 ms</a:t>
+            </a:r>
+            <a:endParaRPr lang="en-US" sz="1100" dirty="0"/>
+          </a:p>
+          <a:p>
+            <a:pPr indent="0" marL="0">
+              <a:buNone/>
+            </a:pPr>
+            <a:r>
+              <a:rPr lang="en-US" sz="1100" dirty="0">
+                <a:solidFill>
+                  <a:srgbClr val="E6EDF3"/>
+                </a:solidFill>
+                <a:latin typeface="Courier New" pitchFamily="34" charset="0"/>
+                <a:ea typeface="Courier New" pitchFamily="34" charset="-122"/>
+                <a:cs typeface="Courier New" pitchFamily="34" charset="-120"/>
+              </a:rPr>
+              <a:t>k3d-p11-agent-3    172.18.0.4   119.493 ms</a:t>
+            </a:r>
+            <a:endParaRPr lang="en-US" sz="1100" dirty="0"/>
+          </a:p>
+          <a:p>
+            <a:pPr indent="0" marL="0">
+              <a:buNone/>
+            </a:pPr>
+            <a:r>
+              <a:rPr lang="en-US" sz="1100" dirty="0">
+                <a:solidFill>
+                  <a:srgbClr val="E6EDF3"/>
+                </a:solidFill>
+                <a:latin typeface="Courier New" pitchFamily="34" charset="0"/>
+                <a:ea typeface="Courier New" pitchFamily="34" charset="-122"/>
+                <a:cs typeface="Courier New" pitchFamily="34" charset="-120"/>
+              </a:rPr>
+              <a:t>k3d-p11-server-0   172.18.0.2   0.060 ms</a:t>
+            </a:r>
+            <a:endParaRPr lang="en-US" sz="1100" dirty="0"/>
           </a:p>
         </p:txBody>
       </p:sp>
@@ -4554,7 +5360,7 @@
                 <a:ea typeface="Courier New" pitchFamily="34" charset="-122"/>
                 <a:cs typeface="Courier New" pitchFamily="34" charset="-120"/>
               </a:rPr>
-              <a:t>      uncordon public node</a:t>
+              <a:t>      uncordon cheapest public node</a:t>
             </a:r>
             <a:endParaRPr lang="en-US" sz="1200" dirty="0"/>
           </a:p>
@@ -4571,7 +5377,7 @@
                 <a:ea typeface="Courier New" pitchFamily="34" charset="-122"/>
                 <a:cs typeface="Courier New" pitchFamily="34" charset="-120"/>
               </a:rPr>
-              <a:t>      add toleration -&gt; any pod</a:t>
+              <a:t>      allow every pod on every node</a:t>
             </a:r>
             <a:endParaRPr lang="en-US" sz="1200" dirty="0"/>
           </a:p>
@@ -4588,7 +5394,7 @@
                 <a:ea typeface="Courier New" pitchFamily="34" charset="-122"/>
                 <a:cs typeface="Courier New" pitchFamily="34" charset="-120"/>
               </a:rPr>
-              <a:t>  if cpu &lt; 40% for 5 min:</a:t>
+              <a:t>  if cpu &lt; 40% for 2 min:</a:t>
             </a:r>
             <a:endParaRPr lang="en-US" sz="1200" dirty="0"/>
           </a:p>
@@ -4605,7 +5411,7 @@
                 <a:ea typeface="Courier New" pitchFamily="34" charset="-122"/>
                 <a:cs typeface="Courier New" pitchFamily="34" charset="-120"/>
               </a:rPr>
-              <a:t>      drain + cordon public node</a:t>
+              <a:t>      drain + cordon priciest public node</a:t>
             </a:r>
             <a:endParaRPr lang="en-US" sz="1200" dirty="0"/>
           </a:p>
@@ -4813,7 +5619,7 @@
                   <a:srgbClr val="4C6A92"/>
                 </a:solidFill>
               </a:rPr>
-              <a:t>Reference burst: 4× private capacity for 3 min, 3 repetitions, mean ± sd</a:t>
+              <a:t>Measured on the testbed: 2× private capacity for 180 s, 3 repetitions, mean ± 95% CI</a:t>
             </a:r>
             <a:endParaRPr lang="en-US" sz="1600" dirty="0"/>
           </a:p>
@@ -4834,7 +5640,7 @@
           </p:nvPr>
         </p:nvGraphicFramePr>
         <p:xfrm>
-          <a:off x="548640" y="1691640"/>
+          <a:off x="548640" y="1645920"/>
           <a:ext cx="11064240" cy="914400"/>
         </p:xfrm>
         <a:graphic>
@@ -4843,14 +5649,14 @@
               <a:tblPr/>
               <a:tblGrid>
                 <a:gridCol w="2286000"/>
-                <a:gridCol w="1508760"/>
-                <a:gridCol w="1508760"/>
                 <a:gridCol w="1600200"/>
+                <a:gridCol w="1463040"/>
+                <a:gridCol w="1463040"/>
                 <a:gridCol w="1417320"/>
-                <a:gridCol w="1371600"/>
-                <a:gridCol w="1371600"/>
+                <a:gridCol w="1417320"/>
+                <a:gridCol w="1417320"/>
               </a:tblGrid>
-              <a:tr h="502920">
+              <a:tr h="457200">
                 <a:tc>
                   <a:txBody>
                     <a:bodyPr/>
@@ -5072,7 +5878,7 @@
                           <a:ea typeface="Calibri" pitchFamily="34" charset="-122"/>
                           <a:cs typeface="Calibri" pitchFamily="34" charset="-120"/>
                         </a:rPr>
-                        <a:t>Rejected / failed req.</a:t>
+                        <a:t>Failed requests</a:t>
                       </a:r>
                       <a:endParaRPr lang="en-US" sz="1300" dirty="0">
                         <a:latin typeface="Calibri" charset="0"/>
@@ -5276,7 +6082,7 @@
                           <a:ea typeface="Calibri" pitchFamily="34" charset="-122"/>
                           <a:cs typeface="Calibri" pitchFamily="34" charset="-120"/>
                         </a:rPr>
-                        <a:t>Attainment per ₹100</a:t>
+                        <a:t>Residency violations</a:t>
                       </a:r>
                       <a:endParaRPr lang="en-US" sz="1300" dirty="0">
                         <a:latin typeface="Calibri" charset="0"/>
@@ -5328,7 +6134,7 @@
                   </a:tcPr>
                 </a:tc>
               </a:tr>
-              <a:tr h="502920">
+              <a:tr h="457200">
                 <a:tc>
                   <a:txBody>
                     <a:bodyPr/>
@@ -5408,13 +6214,13 @@
                       <a:r>
                         <a:rPr lang="en-US" sz="1300" dirty="0">
                           <a:solidFill>
-                            <a:srgbClr val="D1495B"/>
+                            <a:srgbClr val="1B2430"/>
                           </a:solidFill>
                           <a:latin typeface="Calibri" pitchFamily="34" charset="0"/>
                           <a:ea typeface="Calibri" pitchFamily="34" charset="-122"/>
                           <a:cs typeface="Calibri" pitchFamily="34" charset="-120"/>
                         </a:rPr>
-                        <a:t>___</a:t>
+                        <a:t>66.7 ± 14.5</a:t>
                       </a:r>
                       <a:endParaRPr lang="en-US" sz="1300" dirty="0">
                         <a:latin typeface="Calibri" charset="0"/>
@@ -5476,13 +6282,13 @@
                       <a:r>
                         <a:rPr lang="en-US" sz="1300" dirty="0">
                           <a:solidFill>
-                            <a:srgbClr val="D1495B"/>
+                            <a:srgbClr val="1B2430"/>
                           </a:solidFill>
                           <a:latin typeface="Calibri" pitchFamily="34" charset="0"/>
                           <a:ea typeface="Calibri" pitchFamily="34" charset="-122"/>
                           <a:cs typeface="Calibri" pitchFamily="34" charset="-120"/>
                         </a:rPr>
-                        <a:t>___</a:t>
+                        <a:t>1782</a:t>
                       </a:r>
                       <a:endParaRPr lang="en-US" sz="1300" dirty="0">
                         <a:latin typeface="Calibri" charset="0"/>
@@ -5544,13 +6350,13 @@
                       <a:r>
                         <a:rPr lang="en-US" sz="1300" dirty="0">
                           <a:solidFill>
-                            <a:srgbClr val="D1495B"/>
+                            <a:srgbClr val="1B2430"/>
                           </a:solidFill>
                           <a:latin typeface="Calibri" pitchFamily="34" charset="0"/>
                           <a:ea typeface="Calibri" pitchFamily="34" charset="-122"/>
                           <a:cs typeface="Calibri" pitchFamily="34" charset="-120"/>
                         </a:rPr>
-                        <a:t>___</a:t>
+                        <a:t>335</a:t>
                       </a:r>
                       <a:endParaRPr lang="en-US" sz="1300" dirty="0">
                         <a:latin typeface="Calibri" charset="0"/>
@@ -5612,13 +6418,13 @@
                       <a:r>
                         <a:rPr lang="en-US" sz="1300" dirty="0">
                           <a:solidFill>
-                            <a:srgbClr val="D1495B"/>
+                            <a:srgbClr val="1B2430"/>
                           </a:solidFill>
                           <a:latin typeface="Calibri" pitchFamily="34" charset="0"/>
                           <a:ea typeface="Calibri" pitchFamily="34" charset="-122"/>
                           <a:cs typeface="Calibri" pitchFamily="34" charset="-120"/>
                         </a:rPr>
-                        <a:t>___</a:t>
+                        <a:t>0.00</a:t>
                       </a:r>
                       <a:endParaRPr lang="en-US" sz="1300" dirty="0">
                         <a:latin typeface="Calibri" charset="0"/>
@@ -5680,13 +6486,13 @@
                       <a:r>
                         <a:rPr lang="en-US" sz="1300" dirty="0">
                           <a:solidFill>
-                            <a:srgbClr val="D1495B"/>
+                            <a:srgbClr val="1B2430"/>
                           </a:solidFill>
                           <a:latin typeface="Calibri" pitchFamily="34" charset="0"/>
                           <a:ea typeface="Calibri" pitchFamily="34" charset="-122"/>
                           <a:cs typeface="Calibri" pitchFamily="34" charset="-120"/>
                         </a:rPr>
-                        <a:t>___</a:t>
+                        <a:t>0.0</a:t>
                       </a:r>
                       <a:endParaRPr lang="en-US" sz="1300" dirty="0">
                         <a:latin typeface="Calibri" charset="0"/>
@@ -5748,13 +6554,13 @@
                       <a:r>
                         <a:rPr lang="en-US" sz="1300" dirty="0">
                           <a:solidFill>
-                            <a:srgbClr val="D1495B"/>
+                            <a:srgbClr val="1B2430"/>
                           </a:solidFill>
                           <a:latin typeface="Calibri" pitchFamily="34" charset="0"/>
                           <a:ea typeface="Calibri" pitchFamily="34" charset="-122"/>
                           <a:cs typeface="Calibri" pitchFamily="34" charset="-120"/>
                         </a:rPr>
-                        <a:t>___</a:t>
+                        <a:t>0</a:t>
                       </a:r>
                       <a:endParaRPr lang="en-US" sz="1300" dirty="0">
                         <a:latin typeface="Calibri" charset="0"/>
@@ -5806,7 +6612,7 @@
                   </a:tcPr>
                 </a:tc>
               </a:tr>
-              <a:tr h="502920">
+              <a:tr h="457200">
                 <a:tc>
                   <a:txBody>
                     <a:bodyPr/>
@@ -5886,13 +6692,13 @@
                       <a:r>
                         <a:rPr lang="en-US" sz="1300" dirty="0">
                           <a:solidFill>
-                            <a:srgbClr val="D1495B"/>
+                            <a:srgbClr val="1B2430"/>
                           </a:solidFill>
                           <a:latin typeface="Calibri" pitchFamily="34" charset="0"/>
                           <a:ea typeface="Calibri" pitchFamily="34" charset="-122"/>
                           <a:cs typeface="Calibri" pitchFamily="34" charset="-120"/>
                         </a:rPr>
-                        <a:t>___</a:t>
+                        <a:t>92.8 ± 3.5</a:t>
                       </a:r>
                       <a:endParaRPr lang="en-US" sz="1300" dirty="0">
                         <a:latin typeface="Calibri" charset="0"/>
@@ -5954,13 +6760,13 @@
                       <a:r>
                         <a:rPr lang="en-US" sz="1300" dirty="0">
                           <a:solidFill>
-                            <a:srgbClr val="D1495B"/>
+                            <a:srgbClr val="1B2430"/>
                           </a:solidFill>
                           <a:latin typeface="Calibri" pitchFamily="34" charset="0"/>
                           <a:ea typeface="Calibri" pitchFamily="34" charset="-122"/>
                           <a:cs typeface="Calibri" pitchFamily="34" charset="-120"/>
                         </a:rPr>
-                        <a:t>___</a:t>
+                        <a:t>362</a:t>
                       </a:r>
                       <a:endParaRPr lang="en-US" sz="1300" dirty="0">
                         <a:latin typeface="Calibri" charset="0"/>
@@ -6022,13 +6828,13 @@
                       <a:r>
                         <a:rPr lang="en-US" sz="1300" dirty="0">
                           <a:solidFill>
-                            <a:srgbClr val="D1495B"/>
+                            <a:srgbClr val="1B2430"/>
                           </a:solidFill>
                           <a:latin typeface="Calibri" pitchFamily="34" charset="0"/>
                           <a:ea typeface="Calibri" pitchFamily="34" charset="-122"/>
                           <a:cs typeface="Calibri" pitchFamily="34" charset="-120"/>
                         </a:rPr>
-                        <a:t>___</a:t>
+                        <a:t>0</a:t>
                       </a:r>
                       <a:endParaRPr lang="en-US" sz="1300" dirty="0">
                         <a:latin typeface="Calibri" charset="0"/>
@@ -6090,13 +6896,13 @@
                       <a:r>
                         <a:rPr lang="en-US" sz="1300" dirty="0">
                           <a:solidFill>
-                            <a:srgbClr val="D1495B"/>
+                            <a:srgbClr val="1B2430"/>
                           </a:solidFill>
                           <a:latin typeface="Calibri" pitchFamily="34" charset="0"/>
                           <a:ea typeface="Calibri" pitchFamily="34" charset="-122"/>
                           <a:cs typeface="Calibri" pitchFamily="34" charset="-120"/>
                         </a:rPr>
-                        <a:t>___</a:t>
+                        <a:t>0.33</a:t>
                       </a:r>
                       <a:endParaRPr lang="en-US" sz="1300" dirty="0">
                         <a:latin typeface="Calibri" charset="0"/>
@@ -6158,13 +6964,13 @@
                       <a:r>
                         <a:rPr lang="en-US" sz="1300" dirty="0">
                           <a:solidFill>
-                            <a:srgbClr val="D1495B"/>
+                            <a:srgbClr val="1B2430"/>
                           </a:solidFill>
                           <a:latin typeface="Calibri" pitchFamily="34" charset="0"/>
                           <a:ea typeface="Calibri" pitchFamily="34" charset="-122"/>
                           <a:cs typeface="Calibri" pitchFamily="34" charset="-120"/>
                         </a:rPr>
-                        <a:t>___</a:t>
+                        <a:t>44.4</a:t>
                       </a:r>
                       <a:endParaRPr lang="en-US" sz="1300" dirty="0">
                         <a:latin typeface="Calibri" charset="0"/>
@@ -6226,13 +7032,13 @@
                       <a:r>
                         <a:rPr lang="en-US" sz="1300" dirty="0">
                           <a:solidFill>
-                            <a:srgbClr val="D1495B"/>
+                            <a:srgbClr val="1B2430"/>
                           </a:solidFill>
                           <a:latin typeface="Calibri" pitchFamily="34" charset="0"/>
                           <a:ea typeface="Calibri" pitchFamily="34" charset="-122"/>
                           <a:cs typeface="Calibri" pitchFamily="34" charset="-120"/>
                         </a:rPr>
-                        <a:t>___</a:t>
+                        <a:t>7163</a:t>
                       </a:r>
                       <a:endParaRPr lang="en-US" sz="1300" dirty="0">
                         <a:latin typeface="Calibri" charset="0"/>
@@ -6288,209 +7094,36 @@
           </a:graphicData>
         </a:graphic>
       </p:graphicFrame>
-      <p:sp>
-        <p:nvSpPr>
-          <p:cNvPr id="5" name="Shape 2"/>
+      <p:graphicFrame>
+        <p:nvGraphicFramePr>
+          <p:cNvPr id="5" name="Chart 0" descr=""/>
+          <p:cNvGraphicFramePr/>
+          <p:nvPr/>
+        </p:nvGraphicFramePr>
+        <p:xfrm>
+          <a:off x="548640" y="3154680"/>
+          <a:ext cx="6949440" cy="2971800"/>
+        </p:xfrm>
+        <a:graphic xmlns:a="http://schemas.openxmlformats.org/drawingml/2006/main">
+          <a:graphicData uri="http://schemas.openxmlformats.org/drawingml/2006/chart">
+            <c:chart xmlns:c="http://schemas.openxmlformats.org/drawingml/2006/chart" r:id="rId1"/>
+          </a:graphicData>
+        </a:graphic>
+      </p:graphicFrame>
+      <p:sp>
+        <p:nvSpPr>
+          <p:cNvPr id="6" name="Shape 2"/>
           <p:cNvSpPr/>
           <p:nvPr/>
         </p:nvSpPr>
         <p:spPr>
           <a:xfrm>
-            <a:off x="8321040" y="1280160"/>
-            <a:ext cx="3291840" cy="292608"/>
+            <a:off x="7772400" y="3154680"/>
+            <a:ext cx="3840480" cy="2971800"/>
           </a:xfrm>
           <a:prstGeom prst="roundRect">
             <a:avLst>
-              <a:gd name="adj" fmla="val 25000"/>
-            </a:avLst>
-          </a:prstGeom>
-          <a:solidFill>
-            <a:srgbClr val="D1495B"/>
-          </a:solidFill>
-          <a:ln w="12700">
-            <a:solidFill>
-              <a:srgbClr val="D1495B"/>
-            </a:solidFill>
-            <a:prstDash val="solid"/>
-          </a:ln>
-        </p:spPr>
-      </p:sp>
-      <p:sp>
-        <p:nvSpPr>
-          <p:cNvPr id="6" name="Text 3"/>
-          <p:cNvSpPr txBox="1"/>
-          <p:nvPr/>
-        </p:nvSpPr>
-        <p:spPr>
-          <a:xfrm>
-            <a:off x="8321040" y="1280160"/>
-            <a:ext cx="3291840" cy="292608"/>
-          </a:xfrm>
-          <a:prstGeom prst="rect">
-            <a:avLst/>
-          </a:prstGeom>
-          <a:noFill/>
-          <a:ln/>
-        </p:spPr>
-        <p:txBody>
-          <a:bodyPr wrap="square" lIns="0" tIns="0" rIns="0" bIns="0" rtlCol="0" anchor="ctr"/>
-          <a:lstStyle/>
-          <a:p>
-            <a:pPr algn="ctr" indent="0" marL="0">
-              <a:buNone/>
-            </a:pPr>
-            <a:r>
-              <a:rPr lang="en-US" sz="1000" b="1" dirty="0">
-                <a:solidFill>
-                  <a:srgbClr val="FFFFFF"/>
-                </a:solidFill>
-              </a:rPr>
-              <a:t>FILL FROM results/baseline_*.csv</a:t>
-            </a:r>
-            <a:endParaRPr lang="en-US" sz="1000" dirty="0"/>
-          </a:p>
-        </p:txBody>
-      </p:sp>
-      <p:sp>
-        <p:nvSpPr>
-          <p:cNvPr id="7" name="Shape 4"/>
-          <p:cNvSpPr/>
-          <p:nvPr/>
-        </p:nvSpPr>
-        <p:spPr>
-          <a:xfrm>
-            <a:off x="548640" y="3429000"/>
-            <a:ext cx="6766560" cy="2697480"/>
-          </a:xfrm>
-          <a:prstGeom prst="roundRect">
-            <a:avLst>
-              <a:gd name="adj" fmla="val 2712"/>
-            </a:avLst>
-          </a:prstGeom>
-          <a:solidFill>
-            <a:srgbClr val="EEF3F6"/>
-          </a:solidFill>
-          <a:ln w="9525">
-            <a:solidFill>
-              <a:srgbClr val="C9D3DC"/>
-            </a:solidFill>
-            <a:prstDash val="dash"/>
-          </a:ln>
-        </p:spPr>
-      </p:sp>
-      <p:sp>
-        <p:nvSpPr>
-          <p:cNvPr id="8" name="Shape 5"/>
-          <p:cNvSpPr/>
-          <p:nvPr/>
-        </p:nvSpPr>
-        <p:spPr>
-          <a:xfrm>
-            <a:off x="731520" y="3566160"/>
-            <a:ext cx="3291840" cy="292608"/>
-          </a:xfrm>
-          <a:prstGeom prst="roundRect">
-            <a:avLst>
-              <a:gd name="adj" fmla="val 25000"/>
-            </a:avLst>
-          </a:prstGeom>
-          <a:solidFill>
-            <a:srgbClr val="D1495B"/>
-          </a:solidFill>
-          <a:ln w="12700">
-            <a:solidFill>
-              <a:srgbClr val="D1495B"/>
-            </a:solidFill>
-            <a:prstDash val="solid"/>
-          </a:ln>
-        </p:spPr>
-      </p:sp>
-      <p:sp>
-        <p:nvSpPr>
-          <p:cNvPr id="9" name="Text 6"/>
-          <p:cNvSpPr txBox="1"/>
-          <p:nvPr/>
-        </p:nvSpPr>
-        <p:spPr>
-          <a:xfrm>
-            <a:off x="731520" y="3566160"/>
-            <a:ext cx="3291840" cy="292608"/>
-          </a:xfrm>
-          <a:prstGeom prst="rect">
-            <a:avLst/>
-          </a:prstGeom>
-          <a:noFill/>
-          <a:ln/>
-        </p:spPr>
-        <p:txBody>
-          <a:bodyPr wrap="square" lIns="0" tIns="0" rIns="0" bIns="0" rtlCol="0" anchor="ctr"/>
-          <a:lstStyle/>
-          <a:p>
-            <a:pPr algn="ctr" indent="0" marL="0">
-              <a:buNone/>
-            </a:pPr>
-            <a:r>
-              <a:rPr lang="en-US" sz="1000" b="1" dirty="0">
-                <a:solidFill>
-                  <a:srgbClr val="FFFFFF"/>
-                </a:solidFill>
-              </a:rPr>
-              <a:t>INSERT PLOT: latency over time, B0 vs B1</a:t>
-            </a:r>
-            <a:endParaRPr lang="en-US" sz="1000" dirty="0"/>
-          </a:p>
-        </p:txBody>
-      </p:sp>
-      <p:sp>
-        <p:nvSpPr>
-          <p:cNvPr id="10" name="Text 7"/>
-          <p:cNvSpPr txBox="1"/>
-          <p:nvPr/>
-        </p:nvSpPr>
-        <p:spPr>
-          <a:xfrm>
-            <a:off x="822960" y="4114800"/>
-            <a:ext cx="6217920" cy="1737360"/>
-          </a:xfrm>
-          <a:prstGeom prst="rect">
-            <a:avLst/>
-          </a:prstGeom>
-          <a:noFill/>
-          <a:ln/>
-        </p:spPr>
-        <p:txBody>
-          <a:bodyPr wrap="square" lIns="0" tIns="0" rIns="0" bIns="0" rtlCol="0" anchor="ctr"/>
-          <a:lstStyle/>
-          <a:p>
-            <a:pPr algn="ctr" indent="0" marL="0">
-              <a:buNone/>
-            </a:pPr>
-            <a:r>
-              <a:rPr lang="en-US" sz="1300" i="1" dirty="0">
-                <a:solidFill>
-                  <a:srgbClr val="5B6675"/>
-                </a:solidFill>
-              </a:rPr>
-              <a:t>Locust response-time plot across the burst window, with the 300 ms SLO line</a:t>
-            </a:r>
-            <a:endParaRPr lang="en-US" sz="1300" dirty="0"/>
-          </a:p>
-        </p:txBody>
-      </p:sp>
-      <p:sp>
-        <p:nvSpPr>
-          <p:cNvPr id="11" name="Shape 8"/>
-          <p:cNvSpPr/>
-          <p:nvPr/>
-        </p:nvSpPr>
-        <p:spPr>
-          <a:xfrm>
-            <a:off x="7589520" y="3429000"/>
-            <a:ext cx="4023360" cy="2697480"/>
-          </a:xfrm>
-          <a:prstGeom prst="roundRect">
-            <a:avLst>
-              <a:gd name="adj" fmla="val 2712"/>
+              <a:gd name="adj" fmla="val 2462"/>
             </a:avLst>
           </a:prstGeom>
           <a:solidFill>
@@ -6506,14 +7139,14 @@
       </p:sp>
       <p:sp>
         <p:nvSpPr>
-          <p:cNvPr id="12" name="Text 9"/>
+          <p:cNvPr id="7" name="Text 3"/>
           <p:cNvSpPr txBox="1"/>
           <p:nvPr/>
         </p:nvSpPr>
         <p:spPr>
           <a:xfrm>
-            <a:off x="7772400" y="3566160"/>
-            <a:ext cx="3657600" cy="365760"/>
+            <a:off x="7955280" y="3246120"/>
+            <a:ext cx="3474720" cy="365760"/>
           </a:xfrm>
           <a:prstGeom prst="rect">
             <a:avLst/>
@@ -6534,7 +7167,7 @@
                   <a:srgbClr val="12263A"/>
                 </a:solidFill>
               </a:rPr>
-              <a:t>What we expect to see</a:t>
+              <a:t>What the numbers show</a:t>
             </a:r>
             <a:endParaRPr lang="en-US" sz="1600" dirty="0"/>
           </a:p>
@@ -6542,14 +7175,14 @@
       </p:sp>
       <p:sp>
         <p:nvSpPr>
-          <p:cNvPr id="13" name="Text 10"/>
+          <p:cNvPr id="8" name="Text 4"/>
           <p:cNvSpPr txBox="1"/>
           <p:nvPr/>
         </p:nvSpPr>
         <p:spPr>
           <a:xfrm>
-            <a:off x="7772400" y="3977640"/>
-            <a:ext cx="3657600" cy="2057400"/>
+            <a:off x="7955280" y="3657600"/>
+            <a:ext cx="3520440" cy="2377440"/>
           </a:xfrm>
           <a:prstGeom prst="rect">
             <a:avLst/>
@@ -6574,7 +7207,7 @@
                   <a:srgbClr val="1B2430"/>
                 </a:solidFill>
               </a:rPr>
-              <a:t>B0: attainment collapses during the burst; zero spend</a:t>
+              <a:t>Bursting lifts attainment from 67% to 93%</a:t>
             </a:r>
             <a:endParaRPr lang="en-US" sz="1400" dirty="0"/>
           </a:p>
@@ -6592,7 +7225,7 @@
                   <a:srgbClr val="1B2430"/>
                 </a:solidFill>
               </a:rPr>
-              <a:t>B1: attainment recovers, spend grows without bound</a:t>
+              <a:t>B1 spends ₹44.4 per burst with no ceiling check</a:t>
             </a:r>
             <a:endParaRPr lang="en-US" sz="1400" dirty="0"/>
           </a:p>
@@ -6610,7 +7243,7 @@
                   <a:srgbClr val="1B2430"/>
                 </a:solidFill>
               </a:rPr>
-              <a:t>Neither respects residency — the gap PolicyBurst closes</a:t>
+              <a:t>B1 served 7163 restricted requests outside India per run</a:t>
             </a:r>
             <a:endParaRPr lang="en-US" sz="1400" dirty="0"/>
           </a:p>
@@ -10651,7 +11284,7 @@
                   <a:srgbClr val="1B2430"/>
                 </a:solidFill>
               </a:rPr>
-              <a:t>under bursts of 2–6× private capacity with a fixed monthly ceiling.</a:t>
+              <a:t>under bursts of 1.5–4× private capacity with a fixed monthly ceiling.</a:t>
             </a:r>
             <a:endParaRPr lang="en-US" sz="1400" dirty="0"/>
           </a:p>
@@ -20895,7 +21528,7 @@
                   <a:srgbClr val="4C6A92"/>
                 </a:solidFill>
               </a:rPr>
-              <a:t>Private k3s cluster on campus hardware, public free-tier nodes joined over an encrypted overlay</a:t>
+              <a:t>A real 5-node k3s cluster: 2 private nodes and 3 public nodes, every node 2 vCPU</a:t>
             </a:r>
             <a:endParaRPr lang="en-US" sz="1600" dirty="0"/>
           </a:p>
@@ -20958,7 +21591,7 @@
                   <a:srgbClr val="2A9D8F"/>
                 </a:solidFill>
               </a:rPr>
-              <a:t>PRIVATE CAPACITY — on-prem, India</a:t>
+              <a:t>PRIVATE CAPACITY — region IN</a:t>
             </a:r>
             <a:endParaRPr lang="en-US" sz="1300" dirty="0"/>
           </a:p>
@@ -21021,7 +21654,7 @@
                   <a:srgbClr val="1B2430"/>
                 </a:solidFill>
               </a:rPr>
-              <a:t>k3s server (control plane)</a:t>
+              <a:t>server-0: k3s server + control plane</a:t>
             </a:r>
             <a:endParaRPr lang="en-US" sz="1400" dirty="0"/>
           </a:p>
@@ -21084,7 +21717,7 @@
                   <a:srgbClr val="1B2430"/>
                 </a:solidFill>
               </a:rPr>
-              <a:t>k3s agent-1 · agent-2 (Ubuntu VMs)</a:t>
+              <a:t>agent-0: k3s agent</a:t>
             </a:r>
             <a:endParaRPr lang="en-US" sz="1400" dirty="0"/>
           </a:p>
@@ -21147,7 +21780,7 @@
                   <a:srgbClr val="1B2430"/>
                 </a:solidFill>
               </a:rPr>
-              <a:t>Prometheus + metrics-server</a:t>
+              <a:t>metrics-server · HPA (60% CPU, 1–30 pods)</a:t>
             </a:r>
             <a:endParaRPr lang="en-US" sz="1400" dirty="0"/>
           </a:p>
@@ -21210,7 +21843,7 @@
                   <a:srgbClr val="1B2430"/>
                 </a:solidFill>
               </a:rPr>
-              <a:t>PolicyBurst controller (Python)</a:t>
+              <a:t>PolicyBurst controller · Locust (on host)</a:t>
             </a:r>
             <a:endParaRPr lang="en-US" sz="1400" dirty="0"/>
           </a:p>
@@ -21273,7 +21906,7 @@
                   <a:srgbClr val="1B2430"/>
                 </a:solidFill>
               </a:rPr>
-              <a:t>Sample app: 3 services, data-class labels</a:t>
+              <a:t>App: records / lms / static (3 data classes)</a:t>
             </a:r>
             <a:endParaRPr lang="en-US" sz="1400" dirty="0"/>
           </a:p>
@@ -21288,11 +21921,11 @@
         <p:spPr>
           <a:xfrm>
             <a:off x="6492240" y="1691640"/>
-            <a:ext cx="5120640" cy="3017520"/>
+            <a:ext cx="5120640" cy="3246120"/>
           </a:xfrm>
           <a:prstGeom prst="roundRect">
             <a:avLst>
-              <a:gd name="adj" fmla="val 2424"/>
+              <a:gd name="adj" fmla="val 2254"/>
             </a:avLst>
           </a:prstGeom>
           <a:solidFill>
@@ -21336,7 +21969,7 @@
                   <a:srgbClr val="B5761A"/>
                 </a:solidFill>
               </a:rPr>
-              <a:t>PUBLIC OVERFLOW POOL</a:t>
+              <a:t>PUBLIC OVERFLOW POOL — tainted, cordoned until needed</a:t>
             </a:r>
             <a:endParaRPr lang="en-US" sz="1300" dirty="0"/>
           </a:p>
@@ -21351,11 +21984,11 @@
         <p:spPr>
           <a:xfrm>
             <a:off x="6720840" y="2240280"/>
-            <a:ext cx="4663440" cy="1005840"/>
+            <a:ext cx="4663440" cy="731520"/>
           </a:xfrm>
           <a:prstGeom prst="roundRect">
             <a:avLst>
-              <a:gd name="adj" fmla="val 7273"/>
+              <a:gd name="adj" fmla="val 10000"/>
             </a:avLst>
           </a:prstGeom>
           <a:solidFill>
@@ -21377,8 +22010,8 @@
         </p:nvSpPr>
         <p:spPr>
           <a:xfrm>
-            <a:off x="6903720" y="2350008"/>
-            <a:ext cx="4389120" cy="822960"/>
+            <a:off x="6903720" y="2240280"/>
+            <a:ext cx="4389120" cy="731520"/>
           </a:xfrm>
           <a:prstGeom prst="rect">
             <a:avLst/>
@@ -21387,7 +22020,7 @@
           <a:ln/>
         </p:spPr>
         <p:txBody>
-          <a:bodyPr wrap="square" lIns="0" tIns="0" rIns="0" bIns="0" rtlCol="0" anchor="t"/>
+          <a:bodyPr wrap="square" lIns="0" tIns="0" rIns="0" bIns="0" rtlCol="0" anchor="ctr"/>
           <a:lstStyle/>
           <a:p>
             <a:pPr indent="0" marL="0">
@@ -21399,11 +22032,8 @@
                   <a:srgbClr val="1B2430"/>
                 </a:solidFill>
               </a:rPr>
-              <a:t>pub-in: free-tier VM, Indian region</a:t>
+              <a:t>pub-in · agent-1   </a:t>
             </a:r>
-            <a:endParaRPr lang="en-US" sz="1400" dirty="0"/>
-          </a:p>
-          <a:p>
             <a:pPr indent="0" marL="0">
               <a:buNone/>
             </a:pPr>
@@ -21413,7 +22043,7 @@
                   <a:srgbClr val="5B6675"/>
                 </a:solidFill>
               </a:rPr>
-              <a:t>region=IN · tainted burst=public</a:t>
+              <a:t>region IN · no added delay</a:t>
             </a:r>
             <a:endParaRPr lang="en-US" sz="1400" dirty="0"/>
           </a:p>
@@ -21427,12 +22057,12 @@
         </p:nvSpPr>
         <p:spPr>
           <a:xfrm>
-            <a:off x="6720840" y="3429000"/>
-            <a:ext cx="4663440" cy="1005840"/>
+            <a:off x="6720840" y="3108960"/>
+            <a:ext cx="4663440" cy="731520"/>
           </a:xfrm>
           <a:prstGeom prst="roundRect">
             <a:avLst>
-              <a:gd name="adj" fmla="val 7273"/>
+              <a:gd name="adj" fmla="val 10000"/>
             </a:avLst>
           </a:prstGeom>
           <a:solidFill>
@@ -21454,8 +22084,8 @@
         </p:nvSpPr>
         <p:spPr>
           <a:xfrm>
-            <a:off x="6903720" y="3538728"/>
-            <a:ext cx="4389120" cy="822960"/>
+            <a:off x="6903720" y="3108960"/>
+            <a:ext cx="4389120" cy="731520"/>
           </a:xfrm>
           <a:prstGeom prst="rect">
             <a:avLst/>
@@ -21464,7 +22094,7 @@
           <a:ln/>
         </p:spPr>
         <p:txBody>
-          <a:bodyPr wrap="square" lIns="0" tIns="0" rIns="0" bIns="0" rtlCol="0" anchor="t"/>
+          <a:bodyPr wrap="square" lIns="0" tIns="0" rIns="0" bIns="0" rtlCol="0" anchor="ctr"/>
           <a:lstStyle/>
           <a:p>
             <a:pPr indent="0" marL="0">
@@ -21476,11 +22106,8 @@
                   <a:srgbClr val="1B2430"/>
                 </a:solidFill>
               </a:rPr>
-              <a:t>pub-far: same VM + 120 ms netem delay</a:t>
+              <a:t>pub-sg · agent-2   </a:t>
             </a:r>
-            <a:endParaRPr lang="en-US" sz="1400" dirty="0"/>
-          </a:p>
-          <a:p>
             <a:pPr indent="0" marL="0">
               <a:buNone/>
             </a:pPr>
@@ -21490,7 +22117,7 @@
                   <a:srgbClr val="5B6675"/>
                 </a:solidFill>
               </a:rPr>
-              <a:t>region=non-IN (emulated far region)</a:t>
+              <a:t>region non-IN · +40 ms netem</a:t>
             </a:r>
             <a:endParaRPr lang="en-US" sz="1400" dirty="0"/>
           </a:p>
@@ -21498,7 +22125,81 @@
       </p:sp>
       <p:sp>
         <p:nvSpPr>
-          <p:cNvPr id="22" name="Text 20"/>
+          <p:cNvPr id="22" name="Shape 20"/>
+          <p:cNvSpPr/>
+          <p:nvPr/>
+        </p:nvSpPr>
+        <p:spPr>
+          <a:xfrm>
+            <a:off x="6720840" y="3977640"/>
+            <a:ext cx="4663440" cy="731520"/>
+          </a:xfrm>
+          <a:prstGeom prst="roundRect">
+            <a:avLst>
+              <a:gd name="adj" fmla="val 10000"/>
+            </a:avLst>
+          </a:prstGeom>
+          <a:solidFill>
+            <a:srgbClr val="FFFFFF"/>
+          </a:solidFill>
+          <a:ln w="9525">
+            <a:solidFill>
+              <a:srgbClr val="E9A23B"/>
+            </a:solidFill>
+            <a:prstDash val="solid"/>
+          </a:ln>
+        </p:spPr>
+      </p:sp>
+      <p:sp>
+        <p:nvSpPr>
+          <p:cNvPr id="23" name="Text 21"/>
+          <p:cNvSpPr txBox="1"/>
+          <p:nvPr/>
+        </p:nvSpPr>
+        <p:spPr>
+          <a:xfrm>
+            <a:off x="6903720" y="3977640"/>
+            <a:ext cx="4389120" cy="731520"/>
+          </a:xfrm>
+          <a:prstGeom prst="rect">
+            <a:avLst/>
+          </a:prstGeom>
+          <a:noFill/>
+          <a:ln/>
+        </p:spPr>
+        <p:txBody>
+          <a:bodyPr wrap="square" lIns="0" tIns="0" rIns="0" bIns="0" rtlCol="0" anchor="ctr"/>
+          <a:lstStyle/>
+          <a:p>
+            <a:pPr indent="0" marL="0">
+              <a:buNone/>
+            </a:pPr>
+            <a:r>
+              <a:rPr lang="en-US" sz="1400" b="1" dirty="0">
+                <a:solidFill>
+                  <a:srgbClr val="1B2430"/>
+                </a:solidFill>
+              </a:rPr>
+              <a:t>pub-us · agent-3   </a:t>
+            </a:r>
+            <a:pPr indent="0" marL="0">
+              <a:buNone/>
+            </a:pPr>
+            <a:r>
+              <a:rPr lang="en-US" sz="1400" dirty="0">
+                <a:solidFill>
+                  <a:srgbClr val="5B6675"/>
+                </a:solidFill>
+              </a:rPr>
+              <a:t>region non-IN · +120 ms netem</a:t>
+            </a:r>
+            <a:endParaRPr lang="en-US" sz="1400" dirty="0"/>
+          </a:p>
+        </p:txBody>
+      </p:sp>
+      <p:sp>
+        <p:nvSpPr>
+          <p:cNvPr id="24" name="Text 22"/>
           <p:cNvSpPr txBox="1"/>
           <p:nvPr/>
         </p:nvSpPr>
@@ -21526,7 +22227,7 @@
                   <a:srgbClr val="5B6675"/>
                 </a:solidFill>
               </a:rPr>
-              <a:t>WireGuard / Tailscale overlay</a:t>
+              <a:t>Docker bridge + netem</a:t>
             </a:r>
             <a:endParaRPr lang="en-US" sz="1000" dirty="0"/>
           </a:p>
@@ -21534,7 +22235,7 @@
       </p:sp>
       <p:sp>
         <p:nvSpPr>
-          <p:cNvPr id="23" name="Shape 21"/>
+          <p:cNvPr id="25" name="Shape 23"/>
           <p:cNvSpPr/>
           <p:nvPr/>
         </p:nvSpPr>
@@ -21558,7 +22259,7 @@
       </p:sp>
       <p:sp>
         <p:nvSpPr>
-          <p:cNvPr id="24" name="Shape 22"/>
+          <p:cNvPr id="26" name="Shape 24"/>
           <p:cNvSpPr/>
           <p:nvPr/>
         </p:nvSpPr>
@@ -21582,18 +22283,18 @@
       </p:sp>
       <p:sp>
         <p:nvSpPr>
-          <p:cNvPr id="25" name="Shape 23"/>
+          <p:cNvPr id="27" name="Shape 25"/>
           <p:cNvSpPr/>
           <p:nvPr/>
         </p:nvSpPr>
         <p:spPr>
           <a:xfrm>
-            <a:off x="6492240" y="4983480"/>
-            <a:ext cx="5120640" cy="1143000"/>
+            <a:off x="6492240" y="5120640"/>
+            <a:ext cx="5120640" cy="1005840"/>
           </a:xfrm>
           <a:prstGeom prst="roundRect">
             <a:avLst>
-              <a:gd name="adj" fmla="val 6400"/>
+              <a:gd name="adj" fmla="val 7273"/>
             </a:avLst>
           </a:prstGeom>
           <a:solidFill>
@@ -21609,14 +22310,14 @@
       </p:sp>
       <p:sp>
         <p:nvSpPr>
-          <p:cNvPr id="26" name="Text 24"/>
+          <p:cNvPr id="28" name="Text 26"/>
           <p:cNvSpPr txBox="1"/>
           <p:nvPr/>
         </p:nvSpPr>
         <p:spPr>
           <a:xfrm>
-            <a:off x="6720840" y="5074920"/>
-            <a:ext cx="4663440" cy="960120"/>
+            <a:off x="6720840" y="5166360"/>
+            <a:ext cx="4663440" cy="914400"/>
           </a:xfrm>
           <a:prstGeom prst="rect">
             <a:avLst/>
@@ -21632,25 +22333,25 @@
               <a:buNone/>
             </a:pPr>
             <a:r>
-              <a:rPr lang="en-US" sz="1400" b="1" dirty="0">
+              <a:rPr lang="en-US" sz="1300" b="1" dirty="0">
                 <a:solidFill>
                   <a:srgbClr val="1B2430"/>
                 </a:solidFill>
               </a:rPr>
-              <a:t>Locust load generator </a:t>
+              <a:t>Host: </a:t>
             </a:r>
             <a:pPr indent="0" marL="0">
               <a:buNone/>
             </a:pPr>
             <a:r>
-              <a:rPr lang="en-US" sz="1400" dirty="0">
+              <a:rPr lang="en-US" sz="1300" dirty="0">
                 <a:solidFill>
                   <a:srgbClr val="1B2430"/>
                 </a:solidFill>
               </a:rPr>
-              <a:t>drives bursts of 2–6× capacity for 1–5 min against the app ingress; results land in CSV + Prometheus.</a:t>
+              <a:t>DEATHSTAR, WSL2 Ubuntu 26.04, 16 vCPU · k3s v1.35.5 via k3d 5.9 · node CPU capped with docker --cpus</a:t>
             </a:r>
-            <a:endParaRPr lang="en-US" sz="1400" dirty="0"/>
+            <a:endParaRPr lang="en-US" sz="1300" dirty="0"/>
           </a:p>
         </p:txBody>
       </p:sp>

</xml_diff>